<commit_message>
presentation: add full app screen slide and a read-aloud speech script
Speaker wanted text he can read straight off the page rather than
stage directions, plus something to say during the ~40s the analysis
runs, and the full-screen app captures on a slide.

Added slide 3 with the whole interface (sidebar shows provider, model,
key and base URL - that is what the demo narration walks through), and
a speech document in two parts: per-slide text with the closing line
written verbatim, and a demo script whose filler block explains the
three layers while the analysis is still running.

Co-Authored-By: Claude Opus 5 <noreply@anthropic.com>
</commit_message>
<xml_diff>
--- a/presentation/ТЗ-Ревьюер — питч Demo Day.pptx
+++ b/presentation/ТЗ-Ревьюер — питч Demo Day.pptx
@@ -13,9 +13,10 @@
     <p:sldId id="261" r:id="rId7"/>
     <p:sldId id="262" r:id="rId8"/>
     <p:sldId id="263" r:id="rId9"/>
+    <p:sldId id="264" r:id="rId10"/>
   </p:sldIdLst>
   <p:notesMasterIdLst>
-    <p:notesMasterId r:id="rId10"/>
+    <p:notesMasterId r:id="rId11"/>
   </p:notesMasterIdLst>
   <p:sldSz cx="12192000" cy="6858000"/>
   <p:notesSz cx="6858000" cy="12192000"/>
@@ -685,7 +686,7 @@
           <a:p>
             <a:r>
               <a:rPr lang="en-US" dirty="0"/>
-              <a:t>1:00–3:10 — живое демо. План Б: этот и следующие слайды содержат настоящие экраны инструмента.</a:t>
+              <a:t>Слева выбирается провайдер, модель, ключ и base URL — инструмент не привязан к одной модели. Справа три способа подать ТЗ: вставить текст, загрузить файл, взять пример.</a:t>
             </a:r>
             <a:endParaRPr lang="en-US" dirty="0"/>
           </a:p>
@@ -773,7 +774,7 @@
           <a:p>
             <a:r>
               <a:rPr lang="en-US" dirty="0"/>
-              <a:t>Ключевое доказательство: два раздела одного ТЗ требуют разной задержки. Инструмент привёл обе цитаты и задал вопрос аналитику.</a:t>
+              <a:t>1:00–3:10 — живое демо. План Б: этот и следующие слайды содержат настоящие экраны инструмента.</a:t>
             </a:r>
             <a:endParaRPr lang="en-US" dirty="0"/>
           </a:p>
@@ -861,7 +862,7 @@
           <a:p>
             <a:r>
               <a:rPr lang="en-US" dirty="0"/>
-              <a:t>Настоящий экран инструмента: список замечаний с фильтром по категории, раскрытое замечание с цитатой, объяснением и вопросом аналитику.</a:t>
+              <a:t>Ключевое доказательство: два раздела одного ТЗ требуют разной задержки. Инструмент привёл обе цитаты и задал вопрос аналитику.</a:t>
             </a:r>
             <a:endParaRPr lang="en-US" dirty="0"/>
           </a:p>
@@ -949,7 +950,7 @@
           <a:p>
             <a:r>
               <a:rPr lang="en-US" dirty="0"/>
-              <a:t>Кроме замечаний инструмент детерминированно проверяет 21 раздел шаблона: заполнен, пустой, помечен «не применимо», упомянут вне раздела или не найден.</a:t>
+              <a:t>Настоящий экран инструмента: список замечаний с фильтром по категории, раскрытое замечание с цитатой, объяснением и вопросом аналитику.</a:t>
             </a:r>
             <a:endParaRPr lang="en-US" dirty="0"/>
           </a:p>
@@ -1037,7 +1038,7 @@
           <a:p>
             <a:r>
               <a:rPr lang="en-US" dirty="0"/>
-              <a:t>3:10–4:10. Первые два слоя — обычный код, детерминированы и воспроизводимы. LLM отвечает только за смысл, и каждое его замечание обязано содержать дословную цитату, иначе отбрасывается. Провайдера меняли на живой Gemini без единой правки кода.</a:t>
+              <a:t>Кроме замечаний инструмент детерминированно проверяет 21 раздел шаблона: заполнен, пустой, помечен «не применимо», упомянут вне раздела или не найден.</a:t>
             </a:r>
             <a:endParaRPr lang="en-US" dirty="0"/>
           </a:p>
@@ -1125,7 +1126,7 @@
           <a:p>
             <a:r>
               <a:rPr lang="en-US" dirty="0"/>
-              <a:t>4:10–5:00. Финальная фраза читается дословно, 12–15 секунд.</a:t>
+              <a:t>3:10–4:10. Первые два слоя — обычный код, детерминированы и воспроизводимы. LLM отвечает только за смысл, и каждое его замечание обязано содержать дословную цитату, иначе отбрасывается. Провайдера меняли на живой Gemini без единой правки кода.</a:t>
             </a:r>
             <a:endParaRPr lang="en-US" dirty="0"/>
           </a:p>
@@ -1149,6 +1150,94 @@
             <a:fld id="{F7021451-1387-4CA6-816F-3879F97B5CBC}" type="slidenum">
               <a:rPr lang="en-US"/>
               <a:t>8</a:t>
+            </a:fld>
+            <a:endParaRPr lang="en-US"/>
+          </a:p>
+        </p:txBody>
+      </p:sp>
+    </p:spTree>
+    <p:extLst>
+      <p:ext uri="{BB962C8B-B14F-4D97-AF65-F5344CB8AC3E}">
+        <p14:creationId xmlns:p14="http://schemas.microsoft.com/office/powerpoint/2010/main" val="1024086991"/>
+      </p:ext>
+    </p:extLst>
+  </p:cSld>
+  <p:clrMapOvr>
+    <a:masterClrMapping/>
+  </p:clrMapOvr>
+</p:notes>
+</file>
+
+<file path=ppt/notesSlides/notesSlide9.xml><?xml version="1.0" encoding="utf-8"?>
+<p:notes xmlns:a="http://schemas.openxmlformats.org/drawingml/2006/main" xmlns:r="http://schemas.openxmlformats.org/officeDocument/2006/relationships" xmlns:p="http://schemas.openxmlformats.org/presentationml/2006/main">
+  <p:cSld>
+    <p:spTree>
+      <p:nvGrpSpPr>
+        <p:cNvPr id="1" name=""/>
+        <p:cNvGrpSpPr/>
+        <p:nvPr/>
+      </p:nvGrpSpPr>
+      <p:grpSpPr>
+        <a:xfrm>
+          <a:off x="0" y="0"/>
+          <a:ext cx="0" cy="0"/>
+          <a:chOff x="0" y="0"/>
+          <a:chExt cx="0" cy="0"/>
+        </a:xfrm>
+      </p:grpSpPr>
+      <p:sp>
+        <p:nvSpPr>
+          <p:cNvPr id="2" name="Slide Image Placeholder 1"/>
+          <p:cNvSpPr>
+            <a:spLocks noGrp="1" noRot="1" noChangeAspect="1"/>
+          </p:cNvSpPr>
+          <p:nvPr>
+            <p:ph type="sldImg"/>
+          </p:nvPr>
+        </p:nvSpPr>
+        <p:spPr/>
+      </p:sp>
+      <p:sp>
+        <p:nvSpPr>
+          <p:cNvPr id="3" name="Notes Placeholder 2"/>
+          <p:cNvSpPr>
+            <a:spLocks noGrp="1"/>
+          </p:cNvSpPr>
+          <p:nvPr>
+            <p:ph type="body" idx="1"/>
+          </p:nvPr>
+        </p:nvSpPr>
+        <p:spPr/>
+        <p:txBody>
+          <a:bodyPr/>
+          <a:lstStyle/>
+          <a:p>
+            <a:r>
+              <a:rPr lang="en-US" dirty="0"/>
+              <a:t>4:10–5:00. Финальная фраза читается дословно, 12–15 секунд.</a:t>
+            </a:r>
+            <a:endParaRPr lang="en-US" dirty="0"/>
+          </a:p>
+        </p:txBody>
+      </p:sp>
+      <p:sp>
+        <p:nvSpPr>
+          <p:cNvPr id="4" name="Slide Number Placeholder 3"/>
+          <p:cNvSpPr>
+            <a:spLocks noGrp="1"/>
+          </p:cNvSpPr>
+          <p:nvPr>
+            <p:ph type="sldNum" sz="quarter" idx="10"/>
+          </p:nvPr>
+        </p:nvSpPr>
+        <p:spPr/>
+        <p:txBody>
+          <a:bodyPr/>
+          <a:lstStyle/>
+          <a:p>
+            <a:fld id="{F7021451-1387-4CA6-816F-3879F97B5CBC}" type="slidenum">
+              <a:rPr lang="en-US"/>
+              <a:t>9</a:t>
             </a:fld>
             <a:endParaRPr lang="en-US"/>
           </a:p>
@@ -2557,7 +2646,7 @@
                 <a:ea typeface="Calibri" pitchFamily="34" charset="-122"/>
                 <a:cs typeface="Calibri" pitchFamily="34" charset="-120"/>
               </a:rPr>
-              <a:t>ДЕМО</a:t>
+              <a:t>ИНТЕРФЕЙС</a:t>
             </a:r>
             <a:endParaRPr lang="en-US" sz="1150" dirty="0"/>
           </a:p>
@@ -2601,7 +2690,7 @@
                 <a:ea typeface="Cambria" pitchFamily="34" charset="-122"/>
                 <a:cs typeface="Cambria" pitchFamily="34" charset="-120"/>
               </a:rPr>
-              <a:t>Загрузил ТЗ — получил замечания с цитатами</a:t>
+              <a:t>Один экран: настройки слева, документ справа</a:t>
             </a:r>
             <a:endParaRPr lang="en-US" sz="3200" dirty="0"/>
           </a:p>
@@ -2615,493 +2704,12 @@
         </p:nvSpPr>
         <p:spPr>
           <a:xfrm>
-            <a:off x="658368" y="2057400"/>
-            <a:ext cx="2505456" cy="1234440"/>
+            <a:off x="1188720" y="1737360"/>
+            <a:ext cx="9784080" cy="4873142"/>
           </a:xfrm>
           <a:prstGeom prst="roundRect">
             <a:avLst>
-              <a:gd name="adj" fmla="val 7407"/>
-            </a:avLst>
-          </a:prstGeom>
-          <a:solidFill>
-            <a:srgbClr val="F4F7FA"/>
-          </a:solidFill>
-          <a:ln w="12700">
-            <a:solidFill>
-              <a:srgbClr val="E2E8F0"/>
-            </a:solidFill>
-            <a:prstDash val="solid"/>
-          </a:ln>
-        </p:spPr>
-      </p:sp>
-      <p:sp>
-        <p:nvSpPr>
-          <p:cNvPr id="5" name="Text 3"/>
-          <p:cNvSpPr txBox="1"/>
-          <p:nvPr/>
-        </p:nvSpPr>
-        <p:spPr>
-          <a:xfrm>
-            <a:off x="749808" y="2057400"/>
-            <a:ext cx="2322576" cy="1234440"/>
-          </a:xfrm>
-          <a:prstGeom prst="rect">
-            <a:avLst/>
-          </a:prstGeom>
-          <a:noFill/>
-          <a:ln/>
-        </p:spPr>
-        <p:txBody>
-          <a:bodyPr wrap="square" lIns="0" tIns="0" rIns="0" bIns="0" rtlCol="0" anchor="ctr">
-            <a:normAutofit/>
-          </a:bodyPr>
-          <a:lstStyle/>
-          <a:p>
-            <a:pPr algn="ctr" indent="0" marL="0">
-              <a:lnSpc>
-                <a:spcPct val="115000"/>
-              </a:lnSpc>
-              <a:buNone/>
-            </a:pPr>
-            <a:r>
-              <a:rPr lang="en-US" sz="1800" b="1" dirty="0">
-                <a:solidFill>
-                  <a:srgbClr val="1B2E4A"/>
-                </a:solidFill>
-                <a:latin typeface="Calibri" pitchFamily="34" charset="0"/>
-                <a:ea typeface="Calibri" pitchFamily="34" charset="-122"/>
-                <a:cs typeface="Calibri" pitchFamily="34" charset="-120"/>
-              </a:rPr>
-              <a:t>Аналитик</a:t>
-            </a:r>
-            <a:endParaRPr lang="en-US" sz="1800" dirty="0"/>
-          </a:p>
-          <a:p>
-            <a:pPr algn="ctr" indent="0" marL="0">
-              <a:lnSpc>
-                <a:spcPct val="115000"/>
-              </a:lnSpc>
-              <a:buNone/>
-            </a:pPr>
-            <a:r>
-              <a:rPr lang="en-US" sz="1800" b="1" dirty="0">
-                <a:solidFill>
-                  <a:srgbClr val="1B2E4A"/>
-                </a:solidFill>
-                <a:latin typeface="Calibri" pitchFamily="34" charset="0"/>
-                <a:ea typeface="Calibri" pitchFamily="34" charset="-122"/>
-                <a:cs typeface="Calibri" pitchFamily="34" charset="-120"/>
-              </a:rPr>
-              <a:t>загружает ТЗ</a:t>
-            </a:r>
-            <a:endParaRPr lang="en-US" sz="1800" dirty="0"/>
-          </a:p>
-        </p:txBody>
-      </p:sp>
-      <p:sp>
-        <p:nvSpPr>
-          <p:cNvPr id="6" name="Text 4"/>
-          <p:cNvSpPr txBox="1"/>
-          <p:nvPr/>
-        </p:nvSpPr>
-        <p:spPr>
-          <a:xfrm>
-            <a:off x="3163824" y="2057400"/>
-            <a:ext cx="274320" cy="1234440"/>
-          </a:xfrm>
-          <a:prstGeom prst="rect">
-            <a:avLst/>
-          </a:prstGeom>
-          <a:noFill/>
-          <a:ln/>
-        </p:spPr>
-        <p:txBody>
-          <a:bodyPr wrap="square" lIns="0" tIns="0" rIns="0" bIns="0" rtlCol="0" anchor="ctr"/>
-          <a:lstStyle/>
-          <a:p>
-            <a:pPr algn="ctr" indent="0" marL="0">
-              <a:buNone/>
-            </a:pPr>
-            <a:r>
-              <a:rPr lang="en-US" sz="2400" b="1" dirty="0">
-                <a:solidFill>
-                  <a:srgbClr val="C3CDD9"/>
-                </a:solidFill>
-                <a:latin typeface="Calibri" pitchFamily="34" charset="0"/>
-                <a:ea typeface="Calibri" pitchFamily="34" charset="-122"/>
-                <a:cs typeface="Calibri" pitchFamily="34" charset="-120"/>
-              </a:rPr>
-              <a:t>›</a:t>
-            </a:r>
-            <a:endParaRPr lang="en-US" sz="2400" dirty="0"/>
-          </a:p>
-        </p:txBody>
-      </p:sp>
-      <p:sp>
-        <p:nvSpPr>
-          <p:cNvPr id="7" name="Shape 5"/>
-          <p:cNvSpPr/>
-          <p:nvPr/>
-        </p:nvSpPr>
-        <p:spPr>
-          <a:xfrm>
-            <a:off x="3438144" y="2057400"/>
-            <a:ext cx="2505456" cy="1234440"/>
-          </a:xfrm>
-          <a:prstGeom prst="roundRect">
-            <a:avLst>
-              <a:gd name="adj" fmla="val 7407"/>
-            </a:avLst>
-          </a:prstGeom>
-          <a:solidFill>
-            <a:srgbClr val="F4F7FA"/>
-          </a:solidFill>
-          <a:ln w="12700">
-            <a:solidFill>
-              <a:srgbClr val="E2E8F0"/>
-            </a:solidFill>
-            <a:prstDash val="solid"/>
-          </a:ln>
-        </p:spPr>
-      </p:sp>
-      <p:sp>
-        <p:nvSpPr>
-          <p:cNvPr id="8" name="Text 6"/>
-          <p:cNvSpPr txBox="1"/>
-          <p:nvPr/>
-        </p:nvSpPr>
-        <p:spPr>
-          <a:xfrm>
-            <a:off x="3529584" y="2057400"/>
-            <a:ext cx="2322576" cy="1234440"/>
-          </a:xfrm>
-          <a:prstGeom prst="rect">
-            <a:avLst/>
-          </a:prstGeom>
-          <a:noFill/>
-          <a:ln/>
-        </p:spPr>
-        <p:txBody>
-          <a:bodyPr wrap="square" lIns="0" tIns="0" rIns="0" bIns="0" rtlCol="0" anchor="ctr">
-            <a:normAutofit/>
-          </a:bodyPr>
-          <a:lstStyle/>
-          <a:p>
-            <a:pPr algn="ctr" indent="0" marL="0">
-              <a:lnSpc>
-                <a:spcPct val="115000"/>
-              </a:lnSpc>
-              <a:buNone/>
-            </a:pPr>
-            <a:r>
-              <a:rPr lang="en-US" sz="1800" b="1" dirty="0">
-                <a:solidFill>
-                  <a:srgbClr val="1B2E4A"/>
-                </a:solidFill>
-                <a:latin typeface="Calibri" pitchFamily="34" charset="0"/>
-                <a:ea typeface="Calibri" pitchFamily="34" charset="-122"/>
-                <a:cs typeface="Calibri" pitchFamily="34" charset="-120"/>
-              </a:rPr>
-              <a:t>Нажимает</a:t>
-            </a:r>
-            <a:endParaRPr lang="en-US" sz="1800" dirty="0"/>
-          </a:p>
-          <a:p>
-            <a:pPr algn="ctr" indent="0" marL="0">
-              <a:lnSpc>
-                <a:spcPct val="115000"/>
-              </a:lnSpc>
-              <a:buNone/>
-            </a:pPr>
-            <a:r>
-              <a:rPr lang="en-US" sz="1800" b="1" dirty="0">
-                <a:solidFill>
-                  <a:srgbClr val="1B2E4A"/>
-                </a:solidFill>
-                <a:latin typeface="Calibri" pitchFamily="34" charset="0"/>
-                <a:ea typeface="Calibri" pitchFamily="34" charset="-122"/>
-                <a:cs typeface="Calibri" pitchFamily="34" charset="-120"/>
-              </a:rPr>
-              <a:t>«Проверить»</a:t>
-            </a:r>
-            <a:endParaRPr lang="en-US" sz="1800" dirty="0"/>
-          </a:p>
-        </p:txBody>
-      </p:sp>
-      <p:sp>
-        <p:nvSpPr>
-          <p:cNvPr id="9" name="Text 7"/>
-          <p:cNvSpPr txBox="1"/>
-          <p:nvPr/>
-        </p:nvSpPr>
-        <p:spPr>
-          <a:xfrm>
-            <a:off x="5943600" y="2057400"/>
-            <a:ext cx="274320" cy="1234440"/>
-          </a:xfrm>
-          <a:prstGeom prst="rect">
-            <a:avLst/>
-          </a:prstGeom>
-          <a:noFill/>
-          <a:ln/>
-        </p:spPr>
-        <p:txBody>
-          <a:bodyPr wrap="square" lIns="0" tIns="0" rIns="0" bIns="0" rtlCol="0" anchor="ctr"/>
-          <a:lstStyle/>
-          <a:p>
-            <a:pPr algn="ctr" indent="0" marL="0">
-              <a:buNone/>
-            </a:pPr>
-            <a:r>
-              <a:rPr lang="en-US" sz="2400" b="1" dirty="0">
-                <a:solidFill>
-                  <a:srgbClr val="C3CDD9"/>
-                </a:solidFill>
-                <a:latin typeface="Calibri" pitchFamily="34" charset="0"/>
-                <a:ea typeface="Calibri" pitchFamily="34" charset="-122"/>
-                <a:cs typeface="Calibri" pitchFamily="34" charset="-120"/>
-              </a:rPr>
-              <a:t>›</a:t>
-            </a:r>
-            <a:endParaRPr lang="en-US" sz="2400" dirty="0"/>
-          </a:p>
-        </p:txBody>
-      </p:sp>
-      <p:sp>
-        <p:nvSpPr>
-          <p:cNvPr id="10" name="Shape 8"/>
-          <p:cNvSpPr/>
-          <p:nvPr/>
-        </p:nvSpPr>
-        <p:spPr>
-          <a:xfrm>
-            <a:off x="6217920" y="2057400"/>
-            <a:ext cx="2505456" cy="1234440"/>
-          </a:xfrm>
-          <a:prstGeom prst="roundRect">
-            <a:avLst>
-              <a:gd name="adj" fmla="val 7407"/>
-            </a:avLst>
-          </a:prstGeom>
-          <a:solidFill>
-            <a:srgbClr val="F4F7FA"/>
-          </a:solidFill>
-          <a:ln w="12700">
-            <a:solidFill>
-              <a:srgbClr val="E2E8F0"/>
-            </a:solidFill>
-            <a:prstDash val="solid"/>
-          </a:ln>
-        </p:spPr>
-      </p:sp>
-      <p:sp>
-        <p:nvSpPr>
-          <p:cNvPr id="11" name="Text 9"/>
-          <p:cNvSpPr txBox="1"/>
-          <p:nvPr/>
-        </p:nvSpPr>
-        <p:spPr>
-          <a:xfrm>
-            <a:off x="6309360" y="2057400"/>
-            <a:ext cx="2322576" cy="1234440"/>
-          </a:xfrm>
-          <a:prstGeom prst="rect">
-            <a:avLst/>
-          </a:prstGeom>
-          <a:noFill/>
-          <a:ln/>
-        </p:spPr>
-        <p:txBody>
-          <a:bodyPr wrap="square" lIns="0" tIns="0" rIns="0" bIns="0" rtlCol="0" anchor="ctr">
-            <a:normAutofit/>
-          </a:bodyPr>
-          <a:lstStyle/>
-          <a:p>
-            <a:pPr algn="ctr" indent="0" marL="0">
-              <a:lnSpc>
-                <a:spcPct val="115000"/>
-              </a:lnSpc>
-              <a:buNone/>
-            </a:pPr>
-            <a:r>
-              <a:rPr lang="en-US" sz="1800" b="1" dirty="0">
-                <a:solidFill>
-                  <a:srgbClr val="1B2E4A"/>
-                </a:solidFill>
-                <a:latin typeface="Calibri" pitchFamily="34" charset="0"/>
-                <a:ea typeface="Calibri" pitchFamily="34" charset="-122"/>
-                <a:cs typeface="Calibri" pitchFamily="34" charset="-120"/>
-              </a:rPr>
-              <a:t>Разбор → шаблон</a:t>
-            </a:r>
-            <a:endParaRPr lang="en-US" sz="1800" dirty="0"/>
-          </a:p>
-          <a:p>
-            <a:pPr algn="ctr" indent="0" marL="0">
-              <a:lnSpc>
-                <a:spcPct val="115000"/>
-              </a:lnSpc>
-              <a:buNone/>
-            </a:pPr>
-            <a:r>
-              <a:rPr lang="en-US" sz="1800" b="1" dirty="0">
-                <a:solidFill>
-                  <a:srgbClr val="1B2E4A"/>
-                </a:solidFill>
-                <a:latin typeface="Calibri" pitchFamily="34" charset="0"/>
-                <a:ea typeface="Calibri" pitchFamily="34" charset="-122"/>
-                <a:cs typeface="Calibri" pitchFamily="34" charset="-120"/>
-              </a:rPr>
-              <a:t>→ LLM</a:t>
-            </a:r>
-            <a:endParaRPr lang="en-US" sz="1800" dirty="0"/>
-          </a:p>
-        </p:txBody>
-      </p:sp>
-      <p:sp>
-        <p:nvSpPr>
-          <p:cNvPr id="12" name="Text 10"/>
-          <p:cNvSpPr txBox="1"/>
-          <p:nvPr/>
-        </p:nvSpPr>
-        <p:spPr>
-          <a:xfrm>
-            <a:off x="8723376" y="2057400"/>
-            <a:ext cx="274320" cy="1234440"/>
-          </a:xfrm>
-          <a:prstGeom prst="rect">
-            <a:avLst/>
-          </a:prstGeom>
-          <a:noFill/>
-          <a:ln/>
-        </p:spPr>
-        <p:txBody>
-          <a:bodyPr wrap="square" lIns="0" tIns="0" rIns="0" bIns="0" rtlCol="0" anchor="ctr"/>
-          <a:lstStyle/>
-          <a:p>
-            <a:pPr algn="ctr" indent="0" marL="0">
-              <a:buNone/>
-            </a:pPr>
-            <a:r>
-              <a:rPr lang="en-US" sz="2400" b="1" dirty="0">
-                <a:solidFill>
-                  <a:srgbClr val="C3CDD9"/>
-                </a:solidFill>
-                <a:latin typeface="Calibri" pitchFamily="34" charset="0"/>
-                <a:ea typeface="Calibri" pitchFamily="34" charset="-122"/>
-                <a:cs typeface="Calibri" pitchFamily="34" charset="-120"/>
-              </a:rPr>
-              <a:t>›</a:t>
-            </a:r>
-            <a:endParaRPr lang="en-US" sz="2400" dirty="0"/>
-          </a:p>
-        </p:txBody>
-      </p:sp>
-      <p:sp>
-        <p:nvSpPr>
-          <p:cNvPr id="13" name="Shape 11"/>
-          <p:cNvSpPr/>
-          <p:nvPr/>
-        </p:nvSpPr>
-        <p:spPr>
-          <a:xfrm>
-            <a:off x="8997696" y="2057400"/>
-            <a:ext cx="2505456" cy="1234440"/>
-          </a:xfrm>
-          <a:prstGeom prst="roundRect">
-            <a:avLst>
-              <a:gd name="adj" fmla="val 7407"/>
-            </a:avLst>
-          </a:prstGeom>
-          <a:solidFill>
-            <a:srgbClr val="E9F4EF"/>
-          </a:solidFill>
-          <a:ln w="19050">
-            <a:solidFill>
-              <a:srgbClr val="2E7D5B"/>
-            </a:solidFill>
-            <a:prstDash val="solid"/>
-          </a:ln>
-        </p:spPr>
-      </p:sp>
-      <p:sp>
-        <p:nvSpPr>
-          <p:cNvPr id="14" name="Text 12"/>
-          <p:cNvSpPr txBox="1"/>
-          <p:nvPr/>
-        </p:nvSpPr>
-        <p:spPr>
-          <a:xfrm>
-            <a:off x="9089136" y="2057400"/>
-            <a:ext cx="2322576" cy="1234440"/>
-          </a:xfrm>
-          <a:prstGeom prst="rect">
-            <a:avLst/>
-          </a:prstGeom>
-          <a:noFill/>
-          <a:ln/>
-        </p:spPr>
-        <p:txBody>
-          <a:bodyPr wrap="square" lIns="0" tIns="0" rIns="0" bIns="0" rtlCol="0" anchor="ctr">
-            <a:normAutofit/>
-          </a:bodyPr>
-          <a:lstStyle/>
-          <a:p>
-            <a:pPr algn="ctr" indent="0" marL="0">
-              <a:lnSpc>
-                <a:spcPct val="115000"/>
-              </a:lnSpc>
-              <a:buNone/>
-            </a:pPr>
-            <a:r>
-              <a:rPr lang="en-US" sz="1800" b="1" dirty="0">
-                <a:solidFill>
-                  <a:srgbClr val="1F5C44"/>
-                </a:solidFill>
-                <a:latin typeface="Calibri" pitchFamily="34" charset="0"/>
-                <a:ea typeface="Calibri" pitchFamily="34" charset="-122"/>
-                <a:cs typeface="Calibri" pitchFamily="34" charset="-120"/>
-              </a:rPr>
-              <a:t>Замечания</a:t>
-            </a:r>
-            <a:endParaRPr lang="en-US" sz="1800" dirty="0"/>
-          </a:p>
-          <a:p>
-            <a:pPr algn="ctr" indent="0" marL="0">
-              <a:lnSpc>
-                <a:spcPct val="115000"/>
-              </a:lnSpc>
-              <a:buNone/>
-            </a:pPr>
-            <a:r>
-              <a:rPr lang="en-US" sz="1800" b="1" dirty="0">
-                <a:solidFill>
-                  <a:srgbClr val="1F5C44"/>
-                </a:solidFill>
-                <a:latin typeface="Calibri" pitchFamily="34" charset="0"/>
-                <a:ea typeface="Calibri" pitchFamily="34" charset="-122"/>
-                <a:cs typeface="Calibri" pitchFamily="34" charset="-120"/>
-              </a:rPr>
-              <a:t>с цитатами</a:t>
-            </a:r>
-            <a:endParaRPr lang="en-US" sz="1800" dirty="0"/>
-          </a:p>
-        </p:txBody>
-      </p:sp>
-      <p:sp>
-        <p:nvSpPr>
-          <p:cNvPr id="15" name="Shape 13"/>
-          <p:cNvSpPr/>
-          <p:nvPr/>
-        </p:nvSpPr>
-        <p:spPr>
-          <a:xfrm>
-            <a:off x="822960" y="3703320"/>
-            <a:ext cx="10515600" cy="3083560"/>
-          </a:xfrm>
-          <a:prstGeom prst="roundRect">
-            <a:avLst>
-              <a:gd name="adj" fmla="val 1483"/>
+              <a:gd name="adj" fmla="val 938"/>
             </a:avLst>
           </a:prstGeom>
           <a:solidFill>
@@ -3124,7 +2732,7 @@
       </p:sp>
       <p:pic>
         <p:nvPicPr>
-          <p:cNvPr id="16" name="Image 0" descr="C:\Masaüstü\tz-reviewer\presentation\assets\ui-result.png">    </p:cNvPr>
+          <p:cNvPr id="5" name="Image 0" descr="C:\Masaüstü\tz-reviewer\presentation\assets\full-input.png">    </p:cNvPr>
           <p:cNvPicPr>
             <a:picLocks noChangeAspect="1"/>
           </p:cNvPicPr>
@@ -3138,8 +2746,8 @@
         </p:blipFill>
         <p:spPr>
           <a:xfrm>
-            <a:off x="868680" y="3749040"/>
-            <a:ext cx="10424160" cy="2992120"/>
+            <a:off x="1234440" y="1783080"/>
+            <a:ext cx="9692640" cy="4781702"/>
           </a:xfrm>
           <a:prstGeom prst="rect">
             <a:avLst/>
@@ -3148,7 +2756,7 @@
       </p:pic>
       <p:sp>
         <p:nvSpPr>
-          <p:cNvPr id="17" name="Text 14"/>
+          <p:cNvPr id="6" name="Text 3"/>
           <p:cNvSpPr txBox="1"/>
           <p:nvPr/>
         </p:nvSpPr>
@@ -3250,7 +2858,7 @@
                 <a:ea typeface="Calibri" pitchFamily="34" charset="-122"/>
                 <a:cs typeface="Calibri" pitchFamily="34" charset="-120"/>
               </a:rPr>
-              <a:t>ЧТО НАХОДИТ · 1</a:t>
+              <a:t>ДЕМО</a:t>
             </a:r>
             <a:endParaRPr lang="en-US" sz="1150" dirty="0"/>
           </a:p>
@@ -3294,7 +2902,7 @@
                 <a:ea typeface="Cambria" pitchFamily="34" charset="-122"/>
                 <a:cs typeface="Cambria" pitchFamily="34" charset="-120"/>
               </a:rPr>
-              <a:t>Противоречие внутри одного документа</a:t>
+              <a:t>Загрузил ТЗ — получил замечания с цитатами</a:t>
             </a:r>
             <a:endParaRPr lang="en-US" sz="3200" dirty="0"/>
           </a:p>
@@ -3308,12 +2916,493 @@
         </p:nvSpPr>
         <p:spPr>
           <a:xfrm>
-            <a:off x="822960" y="1965960"/>
-            <a:ext cx="10515600" cy="4028224"/>
+            <a:off x="658368" y="2057400"/>
+            <a:ext cx="2505456" cy="1234440"/>
           </a:xfrm>
           <a:prstGeom prst="roundRect">
             <a:avLst>
-              <a:gd name="adj" fmla="val 1135"/>
+              <a:gd name="adj" fmla="val 7407"/>
+            </a:avLst>
+          </a:prstGeom>
+          <a:solidFill>
+            <a:srgbClr val="F4F7FA"/>
+          </a:solidFill>
+          <a:ln w="12700">
+            <a:solidFill>
+              <a:srgbClr val="E2E8F0"/>
+            </a:solidFill>
+            <a:prstDash val="solid"/>
+          </a:ln>
+        </p:spPr>
+      </p:sp>
+      <p:sp>
+        <p:nvSpPr>
+          <p:cNvPr id="5" name="Text 3"/>
+          <p:cNvSpPr txBox="1"/>
+          <p:nvPr/>
+        </p:nvSpPr>
+        <p:spPr>
+          <a:xfrm>
+            <a:off x="749808" y="2057400"/>
+            <a:ext cx="2322576" cy="1234440"/>
+          </a:xfrm>
+          <a:prstGeom prst="rect">
+            <a:avLst/>
+          </a:prstGeom>
+          <a:noFill/>
+          <a:ln/>
+        </p:spPr>
+        <p:txBody>
+          <a:bodyPr wrap="square" lIns="0" tIns="0" rIns="0" bIns="0" rtlCol="0" anchor="ctr">
+            <a:normAutofit/>
+          </a:bodyPr>
+          <a:lstStyle/>
+          <a:p>
+            <a:pPr algn="ctr" indent="0" marL="0">
+              <a:lnSpc>
+                <a:spcPct val="115000"/>
+              </a:lnSpc>
+              <a:buNone/>
+            </a:pPr>
+            <a:r>
+              <a:rPr lang="en-US" sz="1800" b="1" dirty="0">
+                <a:solidFill>
+                  <a:srgbClr val="1B2E4A"/>
+                </a:solidFill>
+                <a:latin typeface="Calibri" pitchFamily="34" charset="0"/>
+                <a:ea typeface="Calibri" pitchFamily="34" charset="-122"/>
+                <a:cs typeface="Calibri" pitchFamily="34" charset="-120"/>
+              </a:rPr>
+              <a:t>Аналитик</a:t>
+            </a:r>
+            <a:endParaRPr lang="en-US" sz="1800" dirty="0"/>
+          </a:p>
+          <a:p>
+            <a:pPr algn="ctr" indent="0" marL="0">
+              <a:lnSpc>
+                <a:spcPct val="115000"/>
+              </a:lnSpc>
+              <a:buNone/>
+            </a:pPr>
+            <a:r>
+              <a:rPr lang="en-US" sz="1800" b="1" dirty="0">
+                <a:solidFill>
+                  <a:srgbClr val="1B2E4A"/>
+                </a:solidFill>
+                <a:latin typeface="Calibri" pitchFamily="34" charset="0"/>
+                <a:ea typeface="Calibri" pitchFamily="34" charset="-122"/>
+                <a:cs typeface="Calibri" pitchFamily="34" charset="-120"/>
+              </a:rPr>
+              <a:t>загружает ТЗ</a:t>
+            </a:r>
+            <a:endParaRPr lang="en-US" sz="1800" dirty="0"/>
+          </a:p>
+        </p:txBody>
+      </p:sp>
+      <p:sp>
+        <p:nvSpPr>
+          <p:cNvPr id="6" name="Text 4"/>
+          <p:cNvSpPr txBox="1"/>
+          <p:nvPr/>
+        </p:nvSpPr>
+        <p:spPr>
+          <a:xfrm>
+            <a:off x="3163824" y="2057400"/>
+            <a:ext cx="274320" cy="1234440"/>
+          </a:xfrm>
+          <a:prstGeom prst="rect">
+            <a:avLst/>
+          </a:prstGeom>
+          <a:noFill/>
+          <a:ln/>
+        </p:spPr>
+        <p:txBody>
+          <a:bodyPr wrap="square" lIns="0" tIns="0" rIns="0" bIns="0" rtlCol="0" anchor="ctr"/>
+          <a:lstStyle/>
+          <a:p>
+            <a:pPr algn="ctr" indent="0" marL="0">
+              <a:buNone/>
+            </a:pPr>
+            <a:r>
+              <a:rPr lang="en-US" sz="2400" b="1" dirty="0">
+                <a:solidFill>
+                  <a:srgbClr val="C3CDD9"/>
+                </a:solidFill>
+                <a:latin typeface="Calibri" pitchFamily="34" charset="0"/>
+                <a:ea typeface="Calibri" pitchFamily="34" charset="-122"/>
+                <a:cs typeface="Calibri" pitchFamily="34" charset="-120"/>
+              </a:rPr>
+              <a:t>›</a:t>
+            </a:r>
+            <a:endParaRPr lang="en-US" sz="2400" dirty="0"/>
+          </a:p>
+        </p:txBody>
+      </p:sp>
+      <p:sp>
+        <p:nvSpPr>
+          <p:cNvPr id="7" name="Shape 5"/>
+          <p:cNvSpPr/>
+          <p:nvPr/>
+        </p:nvSpPr>
+        <p:spPr>
+          <a:xfrm>
+            <a:off x="3438144" y="2057400"/>
+            <a:ext cx="2505456" cy="1234440"/>
+          </a:xfrm>
+          <a:prstGeom prst="roundRect">
+            <a:avLst>
+              <a:gd name="adj" fmla="val 7407"/>
+            </a:avLst>
+          </a:prstGeom>
+          <a:solidFill>
+            <a:srgbClr val="F4F7FA"/>
+          </a:solidFill>
+          <a:ln w="12700">
+            <a:solidFill>
+              <a:srgbClr val="E2E8F0"/>
+            </a:solidFill>
+            <a:prstDash val="solid"/>
+          </a:ln>
+        </p:spPr>
+      </p:sp>
+      <p:sp>
+        <p:nvSpPr>
+          <p:cNvPr id="8" name="Text 6"/>
+          <p:cNvSpPr txBox="1"/>
+          <p:nvPr/>
+        </p:nvSpPr>
+        <p:spPr>
+          <a:xfrm>
+            <a:off x="3529584" y="2057400"/>
+            <a:ext cx="2322576" cy="1234440"/>
+          </a:xfrm>
+          <a:prstGeom prst="rect">
+            <a:avLst/>
+          </a:prstGeom>
+          <a:noFill/>
+          <a:ln/>
+        </p:spPr>
+        <p:txBody>
+          <a:bodyPr wrap="square" lIns="0" tIns="0" rIns="0" bIns="0" rtlCol="0" anchor="ctr">
+            <a:normAutofit/>
+          </a:bodyPr>
+          <a:lstStyle/>
+          <a:p>
+            <a:pPr algn="ctr" indent="0" marL="0">
+              <a:lnSpc>
+                <a:spcPct val="115000"/>
+              </a:lnSpc>
+              <a:buNone/>
+            </a:pPr>
+            <a:r>
+              <a:rPr lang="en-US" sz="1800" b="1" dirty="0">
+                <a:solidFill>
+                  <a:srgbClr val="1B2E4A"/>
+                </a:solidFill>
+                <a:latin typeface="Calibri" pitchFamily="34" charset="0"/>
+                <a:ea typeface="Calibri" pitchFamily="34" charset="-122"/>
+                <a:cs typeface="Calibri" pitchFamily="34" charset="-120"/>
+              </a:rPr>
+              <a:t>Нажимает</a:t>
+            </a:r>
+            <a:endParaRPr lang="en-US" sz="1800" dirty="0"/>
+          </a:p>
+          <a:p>
+            <a:pPr algn="ctr" indent="0" marL="0">
+              <a:lnSpc>
+                <a:spcPct val="115000"/>
+              </a:lnSpc>
+              <a:buNone/>
+            </a:pPr>
+            <a:r>
+              <a:rPr lang="en-US" sz="1800" b="1" dirty="0">
+                <a:solidFill>
+                  <a:srgbClr val="1B2E4A"/>
+                </a:solidFill>
+                <a:latin typeface="Calibri" pitchFamily="34" charset="0"/>
+                <a:ea typeface="Calibri" pitchFamily="34" charset="-122"/>
+                <a:cs typeface="Calibri" pitchFamily="34" charset="-120"/>
+              </a:rPr>
+              <a:t>«Проверить»</a:t>
+            </a:r>
+            <a:endParaRPr lang="en-US" sz="1800" dirty="0"/>
+          </a:p>
+        </p:txBody>
+      </p:sp>
+      <p:sp>
+        <p:nvSpPr>
+          <p:cNvPr id="9" name="Text 7"/>
+          <p:cNvSpPr txBox="1"/>
+          <p:nvPr/>
+        </p:nvSpPr>
+        <p:spPr>
+          <a:xfrm>
+            <a:off x="5943600" y="2057400"/>
+            <a:ext cx="274320" cy="1234440"/>
+          </a:xfrm>
+          <a:prstGeom prst="rect">
+            <a:avLst/>
+          </a:prstGeom>
+          <a:noFill/>
+          <a:ln/>
+        </p:spPr>
+        <p:txBody>
+          <a:bodyPr wrap="square" lIns="0" tIns="0" rIns="0" bIns="0" rtlCol="0" anchor="ctr"/>
+          <a:lstStyle/>
+          <a:p>
+            <a:pPr algn="ctr" indent="0" marL="0">
+              <a:buNone/>
+            </a:pPr>
+            <a:r>
+              <a:rPr lang="en-US" sz="2400" b="1" dirty="0">
+                <a:solidFill>
+                  <a:srgbClr val="C3CDD9"/>
+                </a:solidFill>
+                <a:latin typeface="Calibri" pitchFamily="34" charset="0"/>
+                <a:ea typeface="Calibri" pitchFamily="34" charset="-122"/>
+                <a:cs typeface="Calibri" pitchFamily="34" charset="-120"/>
+              </a:rPr>
+              <a:t>›</a:t>
+            </a:r>
+            <a:endParaRPr lang="en-US" sz="2400" dirty="0"/>
+          </a:p>
+        </p:txBody>
+      </p:sp>
+      <p:sp>
+        <p:nvSpPr>
+          <p:cNvPr id="10" name="Shape 8"/>
+          <p:cNvSpPr/>
+          <p:nvPr/>
+        </p:nvSpPr>
+        <p:spPr>
+          <a:xfrm>
+            <a:off x="6217920" y="2057400"/>
+            <a:ext cx="2505456" cy="1234440"/>
+          </a:xfrm>
+          <a:prstGeom prst="roundRect">
+            <a:avLst>
+              <a:gd name="adj" fmla="val 7407"/>
+            </a:avLst>
+          </a:prstGeom>
+          <a:solidFill>
+            <a:srgbClr val="F4F7FA"/>
+          </a:solidFill>
+          <a:ln w="12700">
+            <a:solidFill>
+              <a:srgbClr val="E2E8F0"/>
+            </a:solidFill>
+            <a:prstDash val="solid"/>
+          </a:ln>
+        </p:spPr>
+      </p:sp>
+      <p:sp>
+        <p:nvSpPr>
+          <p:cNvPr id="11" name="Text 9"/>
+          <p:cNvSpPr txBox="1"/>
+          <p:nvPr/>
+        </p:nvSpPr>
+        <p:spPr>
+          <a:xfrm>
+            <a:off x="6309360" y="2057400"/>
+            <a:ext cx="2322576" cy="1234440"/>
+          </a:xfrm>
+          <a:prstGeom prst="rect">
+            <a:avLst/>
+          </a:prstGeom>
+          <a:noFill/>
+          <a:ln/>
+        </p:spPr>
+        <p:txBody>
+          <a:bodyPr wrap="square" lIns="0" tIns="0" rIns="0" bIns="0" rtlCol="0" anchor="ctr">
+            <a:normAutofit/>
+          </a:bodyPr>
+          <a:lstStyle/>
+          <a:p>
+            <a:pPr algn="ctr" indent="0" marL="0">
+              <a:lnSpc>
+                <a:spcPct val="115000"/>
+              </a:lnSpc>
+              <a:buNone/>
+            </a:pPr>
+            <a:r>
+              <a:rPr lang="en-US" sz="1800" b="1" dirty="0">
+                <a:solidFill>
+                  <a:srgbClr val="1B2E4A"/>
+                </a:solidFill>
+                <a:latin typeface="Calibri" pitchFamily="34" charset="0"/>
+                <a:ea typeface="Calibri" pitchFamily="34" charset="-122"/>
+                <a:cs typeface="Calibri" pitchFamily="34" charset="-120"/>
+              </a:rPr>
+              <a:t>Разбор → шаблон</a:t>
+            </a:r>
+            <a:endParaRPr lang="en-US" sz="1800" dirty="0"/>
+          </a:p>
+          <a:p>
+            <a:pPr algn="ctr" indent="0" marL="0">
+              <a:lnSpc>
+                <a:spcPct val="115000"/>
+              </a:lnSpc>
+              <a:buNone/>
+            </a:pPr>
+            <a:r>
+              <a:rPr lang="en-US" sz="1800" b="1" dirty="0">
+                <a:solidFill>
+                  <a:srgbClr val="1B2E4A"/>
+                </a:solidFill>
+                <a:latin typeface="Calibri" pitchFamily="34" charset="0"/>
+                <a:ea typeface="Calibri" pitchFamily="34" charset="-122"/>
+                <a:cs typeface="Calibri" pitchFamily="34" charset="-120"/>
+              </a:rPr>
+              <a:t>→ LLM</a:t>
+            </a:r>
+            <a:endParaRPr lang="en-US" sz="1800" dirty="0"/>
+          </a:p>
+        </p:txBody>
+      </p:sp>
+      <p:sp>
+        <p:nvSpPr>
+          <p:cNvPr id="12" name="Text 10"/>
+          <p:cNvSpPr txBox="1"/>
+          <p:nvPr/>
+        </p:nvSpPr>
+        <p:spPr>
+          <a:xfrm>
+            <a:off x="8723376" y="2057400"/>
+            <a:ext cx="274320" cy="1234440"/>
+          </a:xfrm>
+          <a:prstGeom prst="rect">
+            <a:avLst/>
+          </a:prstGeom>
+          <a:noFill/>
+          <a:ln/>
+        </p:spPr>
+        <p:txBody>
+          <a:bodyPr wrap="square" lIns="0" tIns="0" rIns="0" bIns="0" rtlCol="0" anchor="ctr"/>
+          <a:lstStyle/>
+          <a:p>
+            <a:pPr algn="ctr" indent="0" marL="0">
+              <a:buNone/>
+            </a:pPr>
+            <a:r>
+              <a:rPr lang="en-US" sz="2400" b="1" dirty="0">
+                <a:solidFill>
+                  <a:srgbClr val="C3CDD9"/>
+                </a:solidFill>
+                <a:latin typeface="Calibri" pitchFamily="34" charset="0"/>
+                <a:ea typeface="Calibri" pitchFamily="34" charset="-122"/>
+                <a:cs typeface="Calibri" pitchFamily="34" charset="-120"/>
+              </a:rPr>
+              <a:t>›</a:t>
+            </a:r>
+            <a:endParaRPr lang="en-US" sz="2400" dirty="0"/>
+          </a:p>
+        </p:txBody>
+      </p:sp>
+      <p:sp>
+        <p:nvSpPr>
+          <p:cNvPr id="13" name="Shape 11"/>
+          <p:cNvSpPr/>
+          <p:nvPr/>
+        </p:nvSpPr>
+        <p:spPr>
+          <a:xfrm>
+            <a:off x="8997696" y="2057400"/>
+            <a:ext cx="2505456" cy="1234440"/>
+          </a:xfrm>
+          <a:prstGeom prst="roundRect">
+            <a:avLst>
+              <a:gd name="adj" fmla="val 7407"/>
+            </a:avLst>
+          </a:prstGeom>
+          <a:solidFill>
+            <a:srgbClr val="E9F4EF"/>
+          </a:solidFill>
+          <a:ln w="19050">
+            <a:solidFill>
+              <a:srgbClr val="2E7D5B"/>
+            </a:solidFill>
+            <a:prstDash val="solid"/>
+          </a:ln>
+        </p:spPr>
+      </p:sp>
+      <p:sp>
+        <p:nvSpPr>
+          <p:cNvPr id="14" name="Text 12"/>
+          <p:cNvSpPr txBox="1"/>
+          <p:nvPr/>
+        </p:nvSpPr>
+        <p:spPr>
+          <a:xfrm>
+            <a:off x="9089136" y="2057400"/>
+            <a:ext cx="2322576" cy="1234440"/>
+          </a:xfrm>
+          <a:prstGeom prst="rect">
+            <a:avLst/>
+          </a:prstGeom>
+          <a:noFill/>
+          <a:ln/>
+        </p:spPr>
+        <p:txBody>
+          <a:bodyPr wrap="square" lIns="0" tIns="0" rIns="0" bIns="0" rtlCol="0" anchor="ctr">
+            <a:normAutofit/>
+          </a:bodyPr>
+          <a:lstStyle/>
+          <a:p>
+            <a:pPr algn="ctr" indent="0" marL="0">
+              <a:lnSpc>
+                <a:spcPct val="115000"/>
+              </a:lnSpc>
+              <a:buNone/>
+            </a:pPr>
+            <a:r>
+              <a:rPr lang="en-US" sz="1800" b="1" dirty="0">
+                <a:solidFill>
+                  <a:srgbClr val="1F5C44"/>
+                </a:solidFill>
+                <a:latin typeface="Calibri" pitchFamily="34" charset="0"/>
+                <a:ea typeface="Calibri" pitchFamily="34" charset="-122"/>
+                <a:cs typeface="Calibri" pitchFamily="34" charset="-120"/>
+              </a:rPr>
+              <a:t>Замечания</a:t>
+            </a:r>
+            <a:endParaRPr lang="en-US" sz="1800" dirty="0"/>
+          </a:p>
+          <a:p>
+            <a:pPr algn="ctr" indent="0" marL="0">
+              <a:lnSpc>
+                <a:spcPct val="115000"/>
+              </a:lnSpc>
+              <a:buNone/>
+            </a:pPr>
+            <a:r>
+              <a:rPr lang="en-US" sz="1800" b="1" dirty="0">
+                <a:solidFill>
+                  <a:srgbClr val="1F5C44"/>
+                </a:solidFill>
+                <a:latin typeface="Calibri" pitchFamily="34" charset="0"/>
+                <a:ea typeface="Calibri" pitchFamily="34" charset="-122"/>
+                <a:cs typeface="Calibri" pitchFamily="34" charset="-120"/>
+              </a:rPr>
+              <a:t>с цитатами</a:t>
+            </a:r>
+            <a:endParaRPr lang="en-US" sz="1800" dirty="0"/>
+          </a:p>
+        </p:txBody>
+      </p:sp>
+      <p:sp>
+        <p:nvSpPr>
+          <p:cNvPr id="15" name="Shape 13"/>
+          <p:cNvSpPr/>
+          <p:nvPr/>
+        </p:nvSpPr>
+        <p:spPr>
+          <a:xfrm>
+            <a:off x="822960" y="3703320"/>
+            <a:ext cx="10515600" cy="3083560"/>
+          </a:xfrm>
+          <a:prstGeom prst="roundRect">
+            <a:avLst>
+              <a:gd name="adj" fmla="val 1483"/>
             </a:avLst>
           </a:prstGeom>
           <a:solidFill>
@@ -3336,7 +3425,7 @@
       </p:sp>
       <p:pic>
         <p:nvPicPr>
-          <p:cNvPr id="5" name="Image 0" descr="C:\Masaüstü\tz-reviewer\presentation\assets\llm-output.png">    </p:cNvPr>
+          <p:cNvPr id="16" name="Image 0" descr="C:\Masaüstü\tz-reviewer\presentation\assets\ui-result.png">    </p:cNvPr>
           <p:cNvPicPr>
             <a:picLocks noChangeAspect="1"/>
           </p:cNvPicPr>
@@ -3350,8 +3439,8 @@
         </p:blipFill>
         <p:spPr>
           <a:xfrm>
-            <a:off x="868680" y="2011680"/>
-            <a:ext cx="10424160" cy="3936784"/>
+            <a:off x="868680" y="3749040"/>
+            <a:ext cx="10424160" cy="2992120"/>
           </a:xfrm>
           <a:prstGeom prst="rect">
             <a:avLst/>
@@ -3360,7 +3449,7 @@
       </p:pic>
       <p:sp>
         <p:nvSpPr>
-          <p:cNvPr id="6" name="Text 3"/>
+          <p:cNvPr id="17" name="Text 14"/>
           <p:cNvSpPr txBox="1"/>
           <p:nvPr/>
         </p:nvSpPr>
@@ -3462,7 +3551,7 @@
                 <a:ea typeface="Calibri" pitchFamily="34" charset="-122"/>
                 <a:cs typeface="Calibri" pitchFamily="34" charset="-120"/>
               </a:rPr>
-              <a:t>ИНТЕРФЕЙС</a:t>
+              <a:t>ЧТО НАХОДИТ · 1</a:t>
             </a:r>
             <a:endParaRPr lang="en-US" sz="1150" dirty="0"/>
           </a:p>
@@ -3506,7 +3595,7 @@
                 <a:ea typeface="Cambria" pitchFamily="34" charset="-122"/>
                 <a:cs typeface="Cambria" pitchFamily="34" charset="-120"/>
               </a:rPr>
-              <a:t>Каждое замечание раскрывается до цитаты и вопроса</a:t>
+              <a:t>Противоречие внутри одного документа</a:t>
             </a:r>
             <a:endParaRPr lang="en-US" sz="3200" dirty="0"/>
           </a:p>
@@ -3520,12 +3609,12 @@
         </p:nvSpPr>
         <p:spPr>
           <a:xfrm>
-            <a:off x="1188720" y="1965960"/>
-            <a:ext cx="9784080" cy="4617720"/>
+            <a:off x="822960" y="1965960"/>
+            <a:ext cx="10515600" cy="4028224"/>
           </a:xfrm>
           <a:prstGeom prst="roundRect">
             <a:avLst>
-              <a:gd name="adj" fmla="val 990"/>
+              <a:gd name="adj" fmla="val 1135"/>
             </a:avLst>
           </a:prstGeom>
           <a:solidFill>
@@ -3548,7 +3637,7 @@
       </p:sp>
       <p:pic>
         <p:nvPicPr>
-          <p:cNvPr id="5" name="Image 0" descr="C:\Masaüstü\tz-reviewer\presentation\assets\ui-findings.png">    </p:cNvPr>
+          <p:cNvPr id="5" name="Image 0" descr="C:\Masaüstü\tz-reviewer\presentation\assets\llm-output.png">    </p:cNvPr>
           <p:cNvPicPr>
             <a:picLocks noChangeAspect="1"/>
           </p:cNvPicPr>
@@ -3562,8 +3651,8 @@
         </p:blipFill>
         <p:spPr>
           <a:xfrm>
-            <a:off x="1234440" y="2011680"/>
-            <a:ext cx="9692640" cy="4526280"/>
+            <a:off x="868680" y="2011680"/>
+            <a:ext cx="10424160" cy="3936784"/>
           </a:xfrm>
           <a:prstGeom prst="rect">
             <a:avLst/>
@@ -3674,7 +3763,7 @@
                 <a:ea typeface="Calibri" pitchFamily="34" charset="-122"/>
                 <a:cs typeface="Calibri" pitchFamily="34" charset="-120"/>
               </a:rPr>
-              <a:t>ВТОРОЙ РЕЗУЛЬТАТ</a:t>
+              <a:t>ИНТЕРФЕЙС</a:t>
             </a:r>
             <a:endParaRPr lang="en-US" sz="1150" dirty="0"/>
           </a:p>
@@ -3718,7 +3807,7 @@
                 <a:ea typeface="Cambria" pitchFamily="34" charset="-122"/>
                 <a:cs typeface="Cambria" pitchFamily="34" charset="-120"/>
               </a:rPr>
-              <a:t>Проверка структуры по официальному шаблону МТС</a:t>
+              <a:t>Каждое замечание раскрывается до цитаты и вопроса</a:t>
             </a:r>
             <a:endParaRPr lang="en-US" sz="3200" dirty="0"/>
           </a:p>
@@ -3732,12 +3821,12 @@
         </p:nvSpPr>
         <p:spPr>
           <a:xfrm>
-            <a:off x="1005840" y="2148840"/>
-            <a:ext cx="10149840" cy="3792172"/>
+            <a:off x="1188720" y="1965960"/>
+            <a:ext cx="9784080" cy="4617720"/>
           </a:xfrm>
           <a:prstGeom prst="roundRect">
             <a:avLst>
-              <a:gd name="adj" fmla="val 1206"/>
+              <a:gd name="adj" fmla="val 990"/>
             </a:avLst>
           </a:prstGeom>
           <a:solidFill>
@@ -3760,7 +3849,7 @@
       </p:sp>
       <p:pic>
         <p:nvPicPr>
-          <p:cNvPr id="5" name="Image 0" descr="C:\Masaüstü\tz-reviewer\presentation\assets\ui-coverage.png">    </p:cNvPr>
+          <p:cNvPr id="5" name="Image 0" descr="C:\Masaüstü\tz-reviewer\presentation\assets\ui-findings.png">    </p:cNvPr>
           <p:cNvPicPr>
             <a:picLocks noChangeAspect="1"/>
           </p:cNvPicPr>
@@ -3774,8 +3863,8 @@
         </p:blipFill>
         <p:spPr>
           <a:xfrm>
-            <a:off x="1051560" y="2194560"/>
-            <a:ext cx="10058400" cy="3700732"/>
+            <a:off x="1234440" y="2011680"/>
+            <a:ext cx="9692640" cy="4526280"/>
           </a:xfrm>
           <a:prstGeom prst="rect">
             <a:avLst/>
@@ -3886,7 +3975,7 @@
                 <a:ea typeface="Calibri" pitchFamily="34" charset="-122"/>
                 <a:cs typeface="Calibri" pitchFamily="34" charset="-120"/>
               </a:rPr>
-              <a:t>АРХИТЕКТУРА</a:t>
+              <a:t>ВТОРОЙ РЕЗУЛЬТАТ</a:t>
             </a:r>
             <a:endParaRPr lang="en-US" sz="1150" dirty="0"/>
           </a:p>
@@ -3930,7 +4019,7 @@
                 <a:ea typeface="Cambria" pitchFamily="34" charset="-122"/>
                 <a:cs typeface="Cambria" pitchFamily="34" charset="-120"/>
               </a:rPr>
-              <a:t>Три слоя — и LLM только один из них</a:t>
+              <a:t>Проверка структуры по официальному шаблону МТС</a:t>
             </a:r>
             <a:endParaRPr lang="en-US" sz="3200" dirty="0"/>
           </a:p>
@@ -3944,16 +4033,16 @@
         </p:nvSpPr>
         <p:spPr>
           <a:xfrm>
-            <a:off x="658368" y="2103120"/>
-            <a:ext cx="3407664" cy="2148840"/>
+            <a:off x="1005840" y="2148840"/>
+            <a:ext cx="10149840" cy="3792172"/>
           </a:xfrm>
           <a:prstGeom prst="roundRect">
             <a:avLst>
-              <a:gd name="adj" fmla="val 4255"/>
+              <a:gd name="adj" fmla="val 1206"/>
             </a:avLst>
           </a:prstGeom>
           <a:solidFill>
-            <a:srgbClr val="F4F7FA"/>
+            <a:srgbClr val="FFFFFF"/>
           </a:solidFill>
           <a:ln w="12700">
             <a:solidFill>
@@ -3961,527 +4050,42 @@
             </a:solidFill>
             <a:prstDash val="solid"/>
           </a:ln>
-        </p:spPr>
-      </p:sp>
-      <p:sp>
-        <p:nvSpPr>
-          <p:cNvPr id="5" name="Text 3"/>
-          <p:cNvSpPr txBox="1"/>
-          <p:nvPr/>
-        </p:nvSpPr>
-        <p:spPr>
-          <a:xfrm>
-            <a:off x="914400" y="2304288"/>
-            <a:ext cx="2895600" cy="384048"/>
-          </a:xfrm>
-          <a:prstGeom prst="rect">
-            <a:avLst/>
-          </a:prstGeom>
-          <a:noFill/>
-          <a:ln/>
-        </p:spPr>
-        <p:txBody>
-          <a:bodyPr wrap="square" lIns="0" tIns="0" rIns="0" bIns="0" rtlCol="0" anchor="t"/>
-          <a:lstStyle/>
-          <a:p>
-            <a:pPr indent="0" marL="0">
-              <a:buNone/>
-            </a:pPr>
-            <a:r>
-              <a:rPr lang="en-US" sz="2200" b="1" dirty="0">
-                <a:solidFill>
-                  <a:srgbClr val="B9C4D2"/>
-                </a:solidFill>
-                <a:latin typeface="Cambria" pitchFamily="34" charset="0"/>
-                <a:ea typeface="Cambria" pitchFamily="34" charset="-122"/>
-                <a:cs typeface="Cambria" pitchFamily="34" charset="-120"/>
-              </a:rPr>
-              <a:t>01</a:t>
-            </a:r>
-            <a:endParaRPr lang="en-US" sz="2200" dirty="0"/>
-          </a:p>
-        </p:txBody>
-      </p:sp>
-      <p:sp>
-        <p:nvSpPr>
-          <p:cNvPr id="6" name="Text 4"/>
-          <p:cNvSpPr txBox="1"/>
-          <p:nvPr/>
-        </p:nvSpPr>
-        <p:spPr>
-          <a:xfrm>
-            <a:off x="914400" y="2743200"/>
-            <a:ext cx="2895600" cy="365760"/>
-          </a:xfrm>
-          <a:prstGeom prst="rect">
-            <a:avLst/>
-          </a:prstGeom>
-          <a:noFill/>
-          <a:ln/>
-        </p:spPr>
-        <p:txBody>
-          <a:bodyPr wrap="square" lIns="0" tIns="0" rIns="0" bIns="0" rtlCol="0" anchor="t"/>
-          <a:lstStyle/>
-          <a:p>
-            <a:pPr indent="0" marL="0">
-              <a:buNone/>
-            </a:pPr>
-            <a:r>
-              <a:rPr lang="en-US" sz="2100" b="1" dirty="0">
-                <a:solidFill>
-                  <a:srgbClr val="0E1B2E"/>
-                </a:solidFill>
-                <a:latin typeface="Calibri" pitchFamily="34" charset="0"/>
-                <a:ea typeface="Calibri" pitchFamily="34" charset="-122"/>
-                <a:cs typeface="Calibri" pitchFamily="34" charset="-120"/>
-              </a:rPr>
-              <a:t>Разбор документа</a:t>
-            </a:r>
-            <a:endParaRPr lang="en-US" sz="2100" dirty="0"/>
-          </a:p>
-        </p:txBody>
-      </p:sp>
-      <p:sp>
-        <p:nvSpPr>
-          <p:cNvPr id="7" name="Text 5"/>
-          <p:cNvSpPr txBox="1"/>
-          <p:nvPr/>
-        </p:nvSpPr>
-        <p:spPr>
-          <a:xfrm>
-            <a:off x="914400" y="3182112"/>
-            <a:ext cx="2895600" cy="868680"/>
-          </a:xfrm>
-          <a:prstGeom prst="rect">
-            <a:avLst/>
-          </a:prstGeom>
-          <a:noFill/>
-          <a:ln/>
-        </p:spPr>
-        <p:txBody>
-          <a:bodyPr wrap="square" lIns="0" tIns="0" rIns="0" bIns="0" rtlCol="0" anchor="t"/>
-          <a:lstStyle/>
-          <a:p>
-            <a:pPr indent="0" marL="0">
-              <a:lnSpc>
-                <a:spcPct val="120000"/>
-              </a:lnSpc>
-              <a:buNone/>
-            </a:pPr>
-            <a:r>
-              <a:rPr lang="en-US" sz="1700" dirty="0">
-                <a:solidFill>
-                  <a:srgbClr val="5A6678"/>
-                </a:solidFill>
-                <a:latin typeface="Calibri" pitchFamily="34" charset="0"/>
-                <a:ea typeface="Calibri" pitchFamily="34" charset="-122"/>
-                <a:cs typeface="Calibri" pitchFamily="34" charset="-120"/>
-              </a:rPr>
-              <a:t>Word и Markdown →</a:t>
-            </a:r>
-            <a:endParaRPr lang="en-US" sz="1700" dirty="0"/>
-          </a:p>
-          <a:p>
-            <a:pPr indent="0" marL="0">
-              <a:lnSpc>
-                <a:spcPct val="120000"/>
-              </a:lnSpc>
-              <a:buNone/>
-            </a:pPr>
-            <a:r>
-              <a:rPr lang="en-US" sz="1700" dirty="0">
-                <a:solidFill>
-                  <a:srgbClr val="5A6678"/>
-                </a:solidFill>
-                <a:latin typeface="Calibri" pitchFamily="34" charset="0"/>
-                <a:ea typeface="Calibri" pitchFamily="34" charset="-122"/>
-                <a:cs typeface="Calibri" pitchFamily="34" charset="-120"/>
-              </a:rPr>
-              <a:t>разделы и таблицы</a:t>
-            </a:r>
-            <a:endParaRPr lang="en-US" sz="1700" dirty="0"/>
-          </a:p>
-        </p:txBody>
-      </p:sp>
-      <p:sp>
-        <p:nvSpPr>
-          <p:cNvPr id="8" name="Shape 6"/>
-          <p:cNvSpPr/>
-          <p:nvPr/>
-        </p:nvSpPr>
-        <p:spPr>
-          <a:xfrm>
-            <a:off x="4376928" y="2103120"/>
-            <a:ext cx="3407664" cy="2148840"/>
-          </a:xfrm>
-          <a:prstGeom prst="roundRect">
-            <a:avLst>
-              <a:gd name="adj" fmla="val 4255"/>
-            </a:avLst>
-          </a:prstGeom>
-          <a:solidFill>
-            <a:srgbClr val="F4F7FA"/>
-          </a:solidFill>
-          <a:ln w="12700">
-            <a:solidFill>
-              <a:srgbClr val="E2E8F0"/>
-            </a:solidFill>
-            <a:prstDash val="solid"/>
-          </a:ln>
-        </p:spPr>
-      </p:sp>
-      <p:sp>
-        <p:nvSpPr>
-          <p:cNvPr id="9" name="Text 7"/>
-          <p:cNvSpPr txBox="1"/>
-          <p:nvPr/>
-        </p:nvSpPr>
-        <p:spPr>
-          <a:xfrm>
-            <a:off x="4632960" y="2304288"/>
-            <a:ext cx="2895600" cy="384048"/>
-          </a:xfrm>
-          <a:prstGeom prst="rect">
-            <a:avLst/>
-          </a:prstGeom>
-          <a:noFill/>
-          <a:ln/>
-        </p:spPr>
-        <p:txBody>
-          <a:bodyPr wrap="square" lIns="0" tIns="0" rIns="0" bIns="0" rtlCol="0" anchor="t"/>
-          <a:lstStyle/>
-          <a:p>
-            <a:pPr indent="0" marL="0">
-              <a:buNone/>
-            </a:pPr>
-            <a:r>
-              <a:rPr lang="en-US" sz="2200" b="1" dirty="0">
-                <a:solidFill>
-                  <a:srgbClr val="B9C4D2"/>
-                </a:solidFill>
-                <a:latin typeface="Cambria" pitchFamily="34" charset="0"/>
-                <a:ea typeface="Cambria" pitchFamily="34" charset="-122"/>
-                <a:cs typeface="Cambria" pitchFamily="34" charset="-120"/>
-              </a:rPr>
-              <a:t>02</a:t>
-            </a:r>
-            <a:endParaRPr lang="en-US" sz="2200" dirty="0"/>
-          </a:p>
-        </p:txBody>
-      </p:sp>
-      <p:sp>
-        <p:nvSpPr>
-          <p:cNvPr id="10" name="Text 8"/>
-          <p:cNvSpPr txBox="1"/>
-          <p:nvPr/>
-        </p:nvSpPr>
-        <p:spPr>
-          <a:xfrm>
-            <a:off x="4632960" y="2743200"/>
-            <a:ext cx="2895600" cy="365760"/>
-          </a:xfrm>
-          <a:prstGeom prst="rect">
-            <a:avLst/>
-          </a:prstGeom>
-          <a:noFill/>
-          <a:ln/>
-        </p:spPr>
-        <p:txBody>
-          <a:bodyPr wrap="square" lIns="0" tIns="0" rIns="0" bIns="0" rtlCol="0" anchor="t"/>
-          <a:lstStyle/>
-          <a:p>
-            <a:pPr indent="0" marL="0">
-              <a:buNone/>
-            </a:pPr>
-            <a:r>
-              <a:rPr lang="en-US" sz="2100" b="1" dirty="0">
-                <a:solidFill>
-                  <a:srgbClr val="0E1B2E"/>
-                </a:solidFill>
-                <a:latin typeface="Calibri" pitchFamily="34" charset="0"/>
-                <a:ea typeface="Calibri" pitchFamily="34" charset="-122"/>
-                <a:cs typeface="Calibri" pitchFamily="34" charset="-120"/>
-              </a:rPr>
-              <a:t>Критерии МТС</a:t>
-            </a:r>
-            <a:endParaRPr lang="en-US" sz="2100" dirty="0"/>
-          </a:p>
-        </p:txBody>
-      </p:sp>
-      <p:sp>
-        <p:nvSpPr>
-          <p:cNvPr id="11" name="Text 9"/>
-          <p:cNvSpPr txBox="1"/>
-          <p:nvPr/>
-        </p:nvSpPr>
-        <p:spPr>
-          <a:xfrm>
-            <a:off x="4632960" y="3182112"/>
-            <a:ext cx="2895600" cy="868680"/>
-          </a:xfrm>
-          <a:prstGeom prst="rect">
-            <a:avLst/>
-          </a:prstGeom>
-          <a:noFill/>
-          <a:ln/>
-        </p:spPr>
-        <p:txBody>
-          <a:bodyPr wrap="square" lIns="0" tIns="0" rIns="0" bIns="0" rtlCol="0" anchor="t"/>
-          <a:lstStyle/>
-          <a:p>
-            <a:pPr indent="0" marL="0">
-              <a:lnSpc>
-                <a:spcPct val="120000"/>
-              </a:lnSpc>
-              <a:buNone/>
-            </a:pPr>
-            <a:r>
-              <a:rPr lang="en-US" sz="1700" dirty="0">
-                <a:solidFill>
-                  <a:srgbClr val="5A6678"/>
-                </a:solidFill>
-                <a:latin typeface="Calibri" pitchFamily="34" charset="0"/>
-                <a:ea typeface="Calibri" pitchFamily="34" charset="-122"/>
-                <a:cs typeface="Calibri" pitchFamily="34" charset="-120"/>
-              </a:rPr>
-              <a:t>21 раздел шаблона +</a:t>
-            </a:r>
-            <a:endParaRPr lang="en-US" sz="1700" dirty="0"/>
-          </a:p>
-          <a:p>
-            <a:pPr indent="0" marL="0">
-              <a:lnSpc>
-                <a:spcPct val="120000"/>
-              </a:lnSpc>
-              <a:buNone/>
-            </a:pPr>
-            <a:r>
-              <a:rPr lang="en-US" sz="1700" dirty="0">
-                <a:solidFill>
-                  <a:srgbClr val="5A6678"/>
-                </a:solidFill>
-                <a:latin typeface="Calibri" pitchFamily="34" charset="0"/>
-                <a:ea typeface="Calibri" pitchFamily="34" charset="-122"/>
-                <a:cs typeface="Calibri" pitchFamily="34" charset="-120"/>
-              </a:rPr>
-              <a:t>8 требований кейса</a:t>
-            </a:r>
-            <a:endParaRPr lang="en-US" sz="1700" dirty="0"/>
-          </a:p>
-        </p:txBody>
-      </p:sp>
-      <p:sp>
-        <p:nvSpPr>
-          <p:cNvPr id="12" name="Shape 10"/>
-          <p:cNvSpPr/>
-          <p:nvPr/>
-        </p:nvSpPr>
-        <p:spPr>
-          <a:xfrm>
-            <a:off x="8095488" y="2103120"/>
-            <a:ext cx="3407664" cy="2148840"/>
-          </a:xfrm>
-          <a:prstGeom prst="roundRect">
-            <a:avLst>
-              <a:gd name="adj" fmla="val 4255"/>
-            </a:avLst>
-          </a:prstGeom>
-          <a:solidFill>
-            <a:srgbClr val="FBF3E4"/>
-          </a:solidFill>
-          <a:ln w="19050">
-            <a:solidFill>
-              <a:srgbClr val="C8791A"/>
-            </a:solidFill>
-            <a:prstDash val="solid"/>
-          </a:ln>
-        </p:spPr>
-      </p:sp>
-      <p:sp>
-        <p:nvSpPr>
-          <p:cNvPr id="13" name="Text 11"/>
-          <p:cNvSpPr txBox="1"/>
-          <p:nvPr/>
-        </p:nvSpPr>
-        <p:spPr>
-          <a:xfrm>
-            <a:off x="8351520" y="2304288"/>
-            <a:ext cx="2895600" cy="384048"/>
-          </a:xfrm>
-          <a:prstGeom prst="rect">
-            <a:avLst/>
-          </a:prstGeom>
-          <a:noFill/>
-          <a:ln/>
-        </p:spPr>
-        <p:txBody>
-          <a:bodyPr wrap="square" lIns="0" tIns="0" rIns="0" bIns="0" rtlCol="0" anchor="t"/>
-          <a:lstStyle/>
-          <a:p>
-            <a:pPr indent="0" marL="0">
-              <a:buNone/>
-            </a:pPr>
-            <a:r>
-              <a:rPr lang="en-US" sz="2200" b="1" dirty="0">
-                <a:solidFill>
-                  <a:srgbClr val="C8791A"/>
-                </a:solidFill>
-                <a:latin typeface="Cambria" pitchFamily="34" charset="0"/>
-                <a:ea typeface="Cambria" pitchFamily="34" charset="-122"/>
-                <a:cs typeface="Cambria" pitchFamily="34" charset="-120"/>
-              </a:rPr>
-              <a:t>03</a:t>
-            </a:r>
-            <a:endParaRPr lang="en-US" sz="2200" dirty="0"/>
-          </a:p>
-        </p:txBody>
-      </p:sp>
-      <p:sp>
-        <p:nvSpPr>
-          <p:cNvPr id="14" name="Text 12"/>
-          <p:cNvSpPr txBox="1"/>
-          <p:nvPr/>
-        </p:nvSpPr>
-        <p:spPr>
-          <a:xfrm>
-            <a:off x="8351520" y="2743200"/>
-            <a:ext cx="2895600" cy="365760"/>
-          </a:xfrm>
-          <a:prstGeom prst="rect">
-            <a:avLst/>
-          </a:prstGeom>
-          <a:noFill/>
-          <a:ln/>
-        </p:spPr>
-        <p:txBody>
-          <a:bodyPr wrap="square" lIns="0" tIns="0" rIns="0" bIns="0" rtlCol="0" anchor="t"/>
-          <a:lstStyle/>
-          <a:p>
-            <a:pPr indent="0" marL="0">
-              <a:buNone/>
-            </a:pPr>
-            <a:r>
-              <a:rPr lang="en-US" sz="2100" b="1" dirty="0">
-                <a:solidFill>
-                  <a:srgbClr val="0E1B2E"/>
-                </a:solidFill>
-                <a:latin typeface="Calibri" pitchFamily="34" charset="0"/>
-                <a:ea typeface="Calibri" pitchFamily="34" charset="-122"/>
-                <a:cs typeface="Calibri" pitchFamily="34" charset="-120"/>
-              </a:rPr>
-              <a:t>LLM-ревью</a:t>
-            </a:r>
-            <a:endParaRPr lang="en-US" sz="2100" dirty="0"/>
-          </a:p>
-        </p:txBody>
-      </p:sp>
-      <p:sp>
-        <p:nvSpPr>
-          <p:cNvPr id="15" name="Text 13"/>
-          <p:cNvSpPr txBox="1"/>
-          <p:nvPr/>
-        </p:nvSpPr>
-        <p:spPr>
-          <a:xfrm>
-            <a:off x="8351520" y="3182112"/>
-            <a:ext cx="2895600" cy="868680"/>
-          </a:xfrm>
-          <a:prstGeom prst="rect">
-            <a:avLst/>
-          </a:prstGeom>
-          <a:noFill/>
-          <a:ln/>
-        </p:spPr>
-        <p:txBody>
-          <a:bodyPr wrap="square" lIns="0" tIns="0" rIns="0" bIns="0" rtlCol="0" anchor="t"/>
-          <a:lstStyle/>
-          <a:p>
-            <a:pPr indent="0" marL="0">
-              <a:lnSpc>
-                <a:spcPct val="120000"/>
-              </a:lnSpc>
-              <a:buNone/>
-            </a:pPr>
-            <a:r>
-              <a:rPr lang="en-US" sz="1700" dirty="0">
-                <a:solidFill>
-                  <a:srgbClr val="5A6678"/>
-                </a:solidFill>
-                <a:latin typeface="Calibri" pitchFamily="34" charset="0"/>
-                <a:ea typeface="Calibri" pitchFamily="34" charset="-122"/>
-                <a:cs typeface="Calibri" pitchFamily="34" charset="-120"/>
-              </a:rPr>
-              <a:t>23 категории,</a:t>
-            </a:r>
-            <a:endParaRPr lang="en-US" sz="1700" dirty="0"/>
-          </a:p>
-          <a:p>
-            <a:pPr indent="0" marL="0">
-              <a:lnSpc>
-                <a:spcPct val="120000"/>
-              </a:lnSpc>
-              <a:buNone/>
-            </a:pPr>
-            <a:r>
-              <a:rPr lang="en-US" sz="1700" dirty="0">
-                <a:solidFill>
-                  <a:srgbClr val="5A6678"/>
-                </a:solidFill>
-                <a:latin typeface="Calibri" pitchFamily="34" charset="0"/>
-                <a:ea typeface="Calibri" pitchFamily="34" charset="-122"/>
-                <a:cs typeface="Calibri" pitchFamily="34" charset="-120"/>
-              </a:rPr>
-              <a:t>обязательная цитата</a:t>
-            </a:r>
-            <a:endParaRPr lang="en-US" sz="1700" dirty="0"/>
-          </a:p>
-        </p:txBody>
-      </p:sp>
-      <p:sp>
-        <p:nvSpPr>
-          <p:cNvPr id="16" name="Text 14"/>
-          <p:cNvSpPr txBox="1"/>
-          <p:nvPr/>
-        </p:nvSpPr>
-        <p:spPr>
-          <a:xfrm>
-            <a:off x="658368" y="4800600"/>
-            <a:ext cx="10844784" cy="777240"/>
-          </a:xfrm>
-          <a:prstGeom prst="rect">
-            <a:avLst/>
-          </a:prstGeom>
-          <a:noFill/>
-          <a:ln/>
-        </p:spPr>
-        <p:txBody>
-          <a:bodyPr wrap="square" lIns="0" tIns="0" rIns="0" bIns="0" rtlCol="0" anchor="t"/>
-          <a:lstStyle/>
-          <a:p>
-            <a:pPr indent="0" marL="0">
-              <a:lnSpc>
-                <a:spcPct val="120000"/>
-              </a:lnSpc>
-              <a:buNone/>
-            </a:pPr>
-            <a:r>
-              <a:rPr lang="en-US" sz="2400" dirty="0">
-                <a:solidFill>
-                  <a:srgbClr val="1B2E4A"/>
-                </a:solidFill>
-                <a:latin typeface="Calibri" pitchFamily="34" charset="0"/>
-                <a:ea typeface="Calibri" pitchFamily="34" charset="-122"/>
-                <a:cs typeface="Calibri" pitchFamily="34" charset="-120"/>
-              </a:rPr>
-              <a:t>Структуру и критерии проверяет код. Без доступа к модели инструмент продолжает работать.</a:t>
-            </a:r>
-            <a:endParaRPr lang="en-US" sz="2400" dirty="0"/>
-          </a:p>
-        </p:txBody>
-      </p:sp>
-      <p:sp>
-        <p:nvSpPr>
-          <p:cNvPr id="17" name="Text 15"/>
+          <a:effectLst>
+            <a:outerShdw sx="100000" sy="100000" kx="0" ky="0" algn="bl" rotWithShape="0" blurRad="177800" dist="50800" dir="5400000">
+              <a:srgbClr val="8FA0B5">
+                <a:alpha val="28000"/>
+              </a:srgbClr>
+            </a:outerShdw>
+          </a:effectLst>
+        </p:spPr>
+      </p:sp>
+      <p:pic>
+        <p:nvPicPr>
+          <p:cNvPr id="5" name="Image 0" descr="C:\Masaüstü\tz-reviewer\presentation\assets\ui-coverage.png">    </p:cNvPr>
+          <p:cNvPicPr>
+            <a:picLocks noChangeAspect="1"/>
+          </p:cNvPicPr>
+          <p:nvPr/>
+        </p:nvPicPr>
+        <p:blipFill>
+          <a:blip r:embed="rId1"/>
+          <a:stretch>
+            <a:fillRect/>
+          </a:stretch>
+        </p:blipFill>
+        <p:spPr>
+          <a:xfrm>
+            <a:off x="1051560" y="2194560"/>
+            <a:ext cx="10058400" cy="3700732"/>
+          </a:xfrm>
+          <a:prstGeom prst="rect">
+            <a:avLst/>
+          </a:prstGeom>
+        </p:spPr>
+      </p:pic>
+      <p:sp>
+        <p:nvSpPr>
+          <p:cNvPr id="6" name="Text 3"/>
           <p:cNvSpPr txBox="1"/>
           <p:nvPr/>
         </p:nvSpPr>
@@ -4529,6 +4133,703 @@
 <file path=ppt/slides/slide8.xml><?xml version="1.0" encoding="utf-8"?>
 <p:sld xmlns:a="http://schemas.openxmlformats.org/drawingml/2006/main" xmlns:r="http://schemas.openxmlformats.org/officeDocument/2006/relationships" xmlns:p="http://schemas.openxmlformats.org/presentationml/2006/main">
   <p:cSld name="Slide 8">
+    <p:bg>
+      <p:bgPr>
+        <a:solidFill>
+          <a:srgbClr val="FFFFFF"/>
+        </a:solidFill>
+      </p:bgPr>
+    </p:bg>
+    <p:spTree>
+      <p:nvGrpSpPr>
+        <p:cNvPr id="1" name=""/>
+        <p:cNvGrpSpPr/>
+        <p:nvPr/>
+      </p:nvGrpSpPr>
+      <p:grpSpPr>
+        <a:xfrm>
+          <a:off x="0" y="0"/>
+          <a:ext cx="0" cy="0"/>
+          <a:chOff x="0" y="0"/>
+          <a:chExt cx="0" cy="0"/>
+        </a:xfrm>
+      </p:grpSpPr>
+      <p:sp>
+        <p:nvSpPr>
+          <p:cNvPr id="2" name="Text 0"/>
+          <p:cNvSpPr txBox="1"/>
+          <p:nvPr/>
+        </p:nvSpPr>
+        <p:spPr>
+          <a:xfrm>
+            <a:off x="658368" y="566928"/>
+            <a:ext cx="10844784" cy="274320"/>
+          </a:xfrm>
+          <a:prstGeom prst="rect">
+            <a:avLst/>
+          </a:prstGeom>
+          <a:noFill/>
+          <a:ln/>
+        </p:spPr>
+        <p:txBody>
+          <a:bodyPr wrap="square" lIns="0" tIns="0" rIns="0" bIns="0" rtlCol="0" anchor="t"/>
+          <a:lstStyle/>
+          <a:p>
+            <a:pPr indent="0" marL="0">
+              <a:buNone/>
+            </a:pPr>
+            <a:r>
+              <a:rPr lang="en-US" sz="1150" b="1" spc="400" kern="0" dirty="0">
+                <a:solidFill>
+                  <a:srgbClr val="E5534B"/>
+                </a:solidFill>
+                <a:latin typeface="Calibri" pitchFamily="34" charset="0"/>
+                <a:ea typeface="Calibri" pitchFamily="34" charset="-122"/>
+                <a:cs typeface="Calibri" pitchFamily="34" charset="-120"/>
+              </a:rPr>
+              <a:t>АРХИТЕКТУРА</a:t>
+            </a:r>
+            <a:endParaRPr lang="en-US" sz="1150" dirty="0"/>
+          </a:p>
+        </p:txBody>
+      </p:sp>
+      <p:sp>
+        <p:nvSpPr>
+          <p:cNvPr id="3" name="Text 1"/>
+          <p:cNvSpPr txBox="1"/>
+          <p:nvPr/>
+        </p:nvSpPr>
+        <p:spPr>
+          <a:xfrm>
+            <a:off x="658368" y="914400"/>
+            <a:ext cx="10844784" cy="914400"/>
+          </a:xfrm>
+          <a:prstGeom prst="rect">
+            <a:avLst/>
+          </a:prstGeom>
+          <a:noFill/>
+          <a:ln/>
+        </p:spPr>
+        <p:txBody>
+          <a:bodyPr wrap="square" lIns="0" tIns="0" rIns="0" bIns="0" rtlCol="0" anchor="t">
+            <a:normAutofit/>
+          </a:bodyPr>
+          <a:lstStyle/>
+          <a:p>
+            <a:pPr indent="0" marL="0">
+              <a:lnSpc>
+                <a:spcPct val="106000"/>
+              </a:lnSpc>
+              <a:buNone/>
+            </a:pPr>
+            <a:r>
+              <a:rPr lang="en-US" sz="3200" b="1" dirty="0">
+                <a:solidFill>
+                  <a:srgbClr val="0E1B2E"/>
+                </a:solidFill>
+                <a:latin typeface="Cambria" pitchFamily="34" charset="0"/>
+                <a:ea typeface="Cambria" pitchFamily="34" charset="-122"/>
+                <a:cs typeface="Cambria" pitchFamily="34" charset="-120"/>
+              </a:rPr>
+              <a:t>Три слоя — и LLM только один из них</a:t>
+            </a:r>
+            <a:endParaRPr lang="en-US" sz="3200" dirty="0"/>
+          </a:p>
+        </p:txBody>
+      </p:sp>
+      <p:sp>
+        <p:nvSpPr>
+          <p:cNvPr id="4" name="Shape 2"/>
+          <p:cNvSpPr/>
+          <p:nvPr/>
+        </p:nvSpPr>
+        <p:spPr>
+          <a:xfrm>
+            <a:off x="658368" y="2103120"/>
+            <a:ext cx="3407664" cy="2148840"/>
+          </a:xfrm>
+          <a:prstGeom prst="roundRect">
+            <a:avLst>
+              <a:gd name="adj" fmla="val 4255"/>
+            </a:avLst>
+          </a:prstGeom>
+          <a:solidFill>
+            <a:srgbClr val="F4F7FA"/>
+          </a:solidFill>
+          <a:ln w="12700">
+            <a:solidFill>
+              <a:srgbClr val="E2E8F0"/>
+            </a:solidFill>
+            <a:prstDash val="solid"/>
+          </a:ln>
+        </p:spPr>
+      </p:sp>
+      <p:sp>
+        <p:nvSpPr>
+          <p:cNvPr id="5" name="Text 3"/>
+          <p:cNvSpPr txBox="1"/>
+          <p:nvPr/>
+        </p:nvSpPr>
+        <p:spPr>
+          <a:xfrm>
+            <a:off x="914400" y="2304288"/>
+            <a:ext cx="2895600" cy="384048"/>
+          </a:xfrm>
+          <a:prstGeom prst="rect">
+            <a:avLst/>
+          </a:prstGeom>
+          <a:noFill/>
+          <a:ln/>
+        </p:spPr>
+        <p:txBody>
+          <a:bodyPr wrap="square" lIns="0" tIns="0" rIns="0" bIns="0" rtlCol="0" anchor="t"/>
+          <a:lstStyle/>
+          <a:p>
+            <a:pPr indent="0" marL="0">
+              <a:buNone/>
+            </a:pPr>
+            <a:r>
+              <a:rPr lang="en-US" sz="2200" b="1" dirty="0">
+                <a:solidFill>
+                  <a:srgbClr val="B9C4D2"/>
+                </a:solidFill>
+                <a:latin typeface="Cambria" pitchFamily="34" charset="0"/>
+                <a:ea typeface="Cambria" pitchFamily="34" charset="-122"/>
+                <a:cs typeface="Cambria" pitchFamily="34" charset="-120"/>
+              </a:rPr>
+              <a:t>01</a:t>
+            </a:r>
+            <a:endParaRPr lang="en-US" sz="2200" dirty="0"/>
+          </a:p>
+        </p:txBody>
+      </p:sp>
+      <p:sp>
+        <p:nvSpPr>
+          <p:cNvPr id="6" name="Text 4"/>
+          <p:cNvSpPr txBox="1"/>
+          <p:nvPr/>
+        </p:nvSpPr>
+        <p:spPr>
+          <a:xfrm>
+            <a:off x="914400" y="2743200"/>
+            <a:ext cx="2895600" cy="365760"/>
+          </a:xfrm>
+          <a:prstGeom prst="rect">
+            <a:avLst/>
+          </a:prstGeom>
+          <a:noFill/>
+          <a:ln/>
+        </p:spPr>
+        <p:txBody>
+          <a:bodyPr wrap="square" lIns="0" tIns="0" rIns="0" bIns="0" rtlCol="0" anchor="t"/>
+          <a:lstStyle/>
+          <a:p>
+            <a:pPr indent="0" marL="0">
+              <a:buNone/>
+            </a:pPr>
+            <a:r>
+              <a:rPr lang="en-US" sz="2100" b="1" dirty="0">
+                <a:solidFill>
+                  <a:srgbClr val="0E1B2E"/>
+                </a:solidFill>
+                <a:latin typeface="Calibri" pitchFamily="34" charset="0"/>
+                <a:ea typeface="Calibri" pitchFamily="34" charset="-122"/>
+                <a:cs typeface="Calibri" pitchFamily="34" charset="-120"/>
+              </a:rPr>
+              <a:t>Разбор документа</a:t>
+            </a:r>
+            <a:endParaRPr lang="en-US" sz="2100" dirty="0"/>
+          </a:p>
+        </p:txBody>
+      </p:sp>
+      <p:sp>
+        <p:nvSpPr>
+          <p:cNvPr id="7" name="Text 5"/>
+          <p:cNvSpPr txBox="1"/>
+          <p:nvPr/>
+        </p:nvSpPr>
+        <p:spPr>
+          <a:xfrm>
+            <a:off x="914400" y="3182112"/>
+            <a:ext cx="2895600" cy="868680"/>
+          </a:xfrm>
+          <a:prstGeom prst="rect">
+            <a:avLst/>
+          </a:prstGeom>
+          <a:noFill/>
+          <a:ln/>
+        </p:spPr>
+        <p:txBody>
+          <a:bodyPr wrap="square" lIns="0" tIns="0" rIns="0" bIns="0" rtlCol="0" anchor="t"/>
+          <a:lstStyle/>
+          <a:p>
+            <a:pPr indent="0" marL="0">
+              <a:lnSpc>
+                <a:spcPct val="120000"/>
+              </a:lnSpc>
+              <a:buNone/>
+            </a:pPr>
+            <a:r>
+              <a:rPr lang="en-US" sz="1700" dirty="0">
+                <a:solidFill>
+                  <a:srgbClr val="5A6678"/>
+                </a:solidFill>
+                <a:latin typeface="Calibri" pitchFamily="34" charset="0"/>
+                <a:ea typeface="Calibri" pitchFamily="34" charset="-122"/>
+                <a:cs typeface="Calibri" pitchFamily="34" charset="-120"/>
+              </a:rPr>
+              <a:t>Word и Markdown →</a:t>
+            </a:r>
+            <a:endParaRPr lang="en-US" sz="1700" dirty="0"/>
+          </a:p>
+          <a:p>
+            <a:pPr indent="0" marL="0">
+              <a:lnSpc>
+                <a:spcPct val="120000"/>
+              </a:lnSpc>
+              <a:buNone/>
+            </a:pPr>
+            <a:r>
+              <a:rPr lang="en-US" sz="1700" dirty="0">
+                <a:solidFill>
+                  <a:srgbClr val="5A6678"/>
+                </a:solidFill>
+                <a:latin typeface="Calibri" pitchFamily="34" charset="0"/>
+                <a:ea typeface="Calibri" pitchFamily="34" charset="-122"/>
+                <a:cs typeface="Calibri" pitchFamily="34" charset="-120"/>
+              </a:rPr>
+              <a:t>разделы и таблицы</a:t>
+            </a:r>
+            <a:endParaRPr lang="en-US" sz="1700" dirty="0"/>
+          </a:p>
+        </p:txBody>
+      </p:sp>
+      <p:sp>
+        <p:nvSpPr>
+          <p:cNvPr id="8" name="Shape 6"/>
+          <p:cNvSpPr/>
+          <p:nvPr/>
+        </p:nvSpPr>
+        <p:spPr>
+          <a:xfrm>
+            <a:off x="4376928" y="2103120"/>
+            <a:ext cx="3407664" cy="2148840"/>
+          </a:xfrm>
+          <a:prstGeom prst="roundRect">
+            <a:avLst>
+              <a:gd name="adj" fmla="val 4255"/>
+            </a:avLst>
+          </a:prstGeom>
+          <a:solidFill>
+            <a:srgbClr val="F4F7FA"/>
+          </a:solidFill>
+          <a:ln w="12700">
+            <a:solidFill>
+              <a:srgbClr val="E2E8F0"/>
+            </a:solidFill>
+            <a:prstDash val="solid"/>
+          </a:ln>
+        </p:spPr>
+      </p:sp>
+      <p:sp>
+        <p:nvSpPr>
+          <p:cNvPr id="9" name="Text 7"/>
+          <p:cNvSpPr txBox="1"/>
+          <p:nvPr/>
+        </p:nvSpPr>
+        <p:spPr>
+          <a:xfrm>
+            <a:off x="4632960" y="2304288"/>
+            <a:ext cx="2895600" cy="384048"/>
+          </a:xfrm>
+          <a:prstGeom prst="rect">
+            <a:avLst/>
+          </a:prstGeom>
+          <a:noFill/>
+          <a:ln/>
+        </p:spPr>
+        <p:txBody>
+          <a:bodyPr wrap="square" lIns="0" tIns="0" rIns="0" bIns="0" rtlCol="0" anchor="t"/>
+          <a:lstStyle/>
+          <a:p>
+            <a:pPr indent="0" marL="0">
+              <a:buNone/>
+            </a:pPr>
+            <a:r>
+              <a:rPr lang="en-US" sz="2200" b="1" dirty="0">
+                <a:solidFill>
+                  <a:srgbClr val="B9C4D2"/>
+                </a:solidFill>
+                <a:latin typeface="Cambria" pitchFamily="34" charset="0"/>
+                <a:ea typeface="Cambria" pitchFamily="34" charset="-122"/>
+                <a:cs typeface="Cambria" pitchFamily="34" charset="-120"/>
+              </a:rPr>
+              <a:t>02</a:t>
+            </a:r>
+            <a:endParaRPr lang="en-US" sz="2200" dirty="0"/>
+          </a:p>
+        </p:txBody>
+      </p:sp>
+      <p:sp>
+        <p:nvSpPr>
+          <p:cNvPr id="10" name="Text 8"/>
+          <p:cNvSpPr txBox="1"/>
+          <p:nvPr/>
+        </p:nvSpPr>
+        <p:spPr>
+          <a:xfrm>
+            <a:off x="4632960" y="2743200"/>
+            <a:ext cx="2895600" cy="365760"/>
+          </a:xfrm>
+          <a:prstGeom prst="rect">
+            <a:avLst/>
+          </a:prstGeom>
+          <a:noFill/>
+          <a:ln/>
+        </p:spPr>
+        <p:txBody>
+          <a:bodyPr wrap="square" lIns="0" tIns="0" rIns="0" bIns="0" rtlCol="0" anchor="t"/>
+          <a:lstStyle/>
+          <a:p>
+            <a:pPr indent="0" marL="0">
+              <a:buNone/>
+            </a:pPr>
+            <a:r>
+              <a:rPr lang="en-US" sz="2100" b="1" dirty="0">
+                <a:solidFill>
+                  <a:srgbClr val="0E1B2E"/>
+                </a:solidFill>
+                <a:latin typeface="Calibri" pitchFamily="34" charset="0"/>
+                <a:ea typeface="Calibri" pitchFamily="34" charset="-122"/>
+                <a:cs typeface="Calibri" pitchFamily="34" charset="-120"/>
+              </a:rPr>
+              <a:t>Критерии МТС</a:t>
+            </a:r>
+            <a:endParaRPr lang="en-US" sz="2100" dirty="0"/>
+          </a:p>
+        </p:txBody>
+      </p:sp>
+      <p:sp>
+        <p:nvSpPr>
+          <p:cNvPr id="11" name="Text 9"/>
+          <p:cNvSpPr txBox="1"/>
+          <p:nvPr/>
+        </p:nvSpPr>
+        <p:spPr>
+          <a:xfrm>
+            <a:off x="4632960" y="3182112"/>
+            <a:ext cx="2895600" cy="868680"/>
+          </a:xfrm>
+          <a:prstGeom prst="rect">
+            <a:avLst/>
+          </a:prstGeom>
+          <a:noFill/>
+          <a:ln/>
+        </p:spPr>
+        <p:txBody>
+          <a:bodyPr wrap="square" lIns="0" tIns="0" rIns="0" bIns="0" rtlCol="0" anchor="t"/>
+          <a:lstStyle/>
+          <a:p>
+            <a:pPr indent="0" marL="0">
+              <a:lnSpc>
+                <a:spcPct val="120000"/>
+              </a:lnSpc>
+              <a:buNone/>
+            </a:pPr>
+            <a:r>
+              <a:rPr lang="en-US" sz="1700" dirty="0">
+                <a:solidFill>
+                  <a:srgbClr val="5A6678"/>
+                </a:solidFill>
+                <a:latin typeface="Calibri" pitchFamily="34" charset="0"/>
+                <a:ea typeface="Calibri" pitchFamily="34" charset="-122"/>
+                <a:cs typeface="Calibri" pitchFamily="34" charset="-120"/>
+              </a:rPr>
+              <a:t>21 раздел шаблона +</a:t>
+            </a:r>
+            <a:endParaRPr lang="en-US" sz="1700" dirty="0"/>
+          </a:p>
+          <a:p>
+            <a:pPr indent="0" marL="0">
+              <a:lnSpc>
+                <a:spcPct val="120000"/>
+              </a:lnSpc>
+              <a:buNone/>
+            </a:pPr>
+            <a:r>
+              <a:rPr lang="en-US" sz="1700" dirty="0">
+                <a:solidFill>
+                  <a:srgbClr val="5A6678"/>
+                </a:solidFill>
+                <a:latin typeface="Calibri" pitchFamily="34" charset="0"/>
+                <a:ea typeface="Calibri" pitchFamily="34" charset="-122"/>
+                <a:cs typeface="Calibri" pitchFamily="34" charset="-120"/>
+              </a:rPr>
+              <a:t>8 требований кейса</a:t>
+            </a:r>
+            <a:endParaRPr lang="en-US" sz="1700" dirty="0"/>
+          </a:p>
+        </p:txBody>
+      </p:sp>
+      <p:sp>
+        <p:nvSpPr>
+          <p:cNvPr id="12" name="Shape 10"/>
+          <p:cNvSpPr/>
+          <p:nvPr/>
+        </p:nvSpPr>
+        <p:spPr>
+          <a:xfrm>
+            <a:off x="8095488" y="2103120"/>
+            <a:ext cx="3407664" cy="2148840"/>
+          </a:xfrm>
+          <a:prstGeom prst="roundRect">
+            <a:avLst>
+              <a:gd name="adj" fmla="val 4255"/>
+            </a:avLst>
+          </a:prstGeom>
+          <a:solidFill>
+            <a:srgbClr val="FBF3E4"/>
+          </a:solidFill>
+          <a:ln w="19050">
+            <a:solidFill>
+              <a:srgbClr val="C8791A"/>
+            </a:solidFill>
+            <a:prstDash val="solid"/>
+          </a:ln>
+        </p:spPr>
+      </p:sp>
+      <p:sp>
+        <p:nvSpPr>
+          <p:cNvPr id="13" name="Text 11"/>
+          <p:cNvSpPr txBox="1"/>
+          <p:nvPr/>
+        </p:nvSpPr>
+        <p:spPr>
+          <a:xfrm>
+            <a:off x="8351520" y="2304288"/>
+            <a:ext cx="2895600" cy="384048"/>
+          </a:xfrm>
+          <a:prstGeom prst="rect">
+            <a:avLst/>
+          </a:prstGeom>
+          <a:noFill/>
+          <a:ln/>
+        </p:spPr>
+        <p:txBody>
+          <a:bodyPr wrap="square" lIns="0" tIns="0" rIns="0" bIns="0" rtlCol="0" anchor="t"/>
+          <a:lstStyle/>
+          <a:p>
+            <a:pPr indent="0" marL="0">
+              <a:buNone/>
+            </a:pPr>
+            <a:r>
+              <a:rPr lang="en-US" sz="2200" b="1" dirty="0">
+                <a:solidFill>
+                  <a:srgbClr val="C8791A"/>
+                </a:solidFill>
+                <a:latin typeface="Cambria" pitchFamily="34" charset="0"/>
+                <a:ea typeface="Cambria" pitchFamily="34" charset="-122"/>
+                <a:cs typeface="Cambria" pitchFamily="34" charset="-120"/>
+              </a:rPr>
+              <a:t>03</a:t>
+            </a:r>
+            <a:endParaRPr lang="en-US" sz="2200" dirty="0"/>
+          </a:p>
+        </p:txBody>
+      </p:sp>
+      <p:sp>
+        <p:nvSpPr>
+          <p:cNvPr id="14" name="Text 12"/>
+          <p:cNvSpPr txBox="1"/>
+          <p:nvPr/>
+        </p:nvSpPr>
+        <p:spPr>
+          <a:xfrm>
+            <a:off x="8351520" y="2743200"/>
+            <a:ext cx="2895600" cy="365760"/>
+          </a:xfrm>
+          <a:prstGeom prst="rect">
+            <a:avLst/>
+          </a:prstGeom>
+          <a:noFill/>
+          <a:ln/>
+        </p:spPr>
+        <p:txBody>
+          <a:bodyPr wrap="square" lIns="0" tIns="0" rIns="0" bIns="0" rtlCol="0" anchor="t"/>
+          <a:lstStyle/>
+          <a:p>
+            <a:pPr indent="0" marL="0">
+              <a:buNone/>
+            </a:pPr>
+            <a:r>
+              <a:rPr lang="en-US" sz="2100" b="1" dirty="0">
+                <a:solidFill>
+                  <a:srgbClr val="0E1B2E"/>
+                </a:solidFill>
+                <a:latin typeface="Calibri" pitchFamily="34" charset="0"/>
+                <a:ea typeface="Calibri" pitchFamily="34" charset="-122"/>
+                <a:cs typeface="Calibri" pitchFamily="34" charset="-120"/>
+              </a:rPr>
+              <a:t>LLM-ревью</a:t>
+            </a:r>
+            <a:endParaRPr lang="en-US" sz="2100" dirty="0"/>
+          </a:p>
+        </p:txBody>
+      </p:sp>
+      <p:sp>
+        <p:nvSpPr>
+          <p:cNvPr id="15" name="Text 13"/>
+          <p:cNvSpPr txBox="1"/>
+          <p:nvPr/>
+        </p:nvSpPr>
+        <p:spPr>
+          <a:xfrm>
+            <a:off x="8351520" y="3182112"/>
+            <a:ext cx="2895600" cy="868680"/>
+          </a:xfrm>
+          <a:prstGeom prst="rect">
+            <a:avLst/>
+          </a:prstGeom>
+          <a:noFill/>
+          <a:ln/>
+        </p:spPr>
+        <p:txBody>
+          <a:bodyPr wrap="square" lIns="0" tIns="0" rIns="0" bIns="0" rtlCol="0" anchor="t"/>
+          <a:lstStyle/>
+          <a:p>
+            <a:pPr indent="0" marL="0">
+              <a:lnSpc>
+                <a:spcPct val="120000"/>
+              </a:lnSpc>
+              <a:buNone/>
+            </a:pPr>
+            <a:r>
+              <a:rPr lang="en-US" sz="1700" dirty="0">
+                <a:solidFill>
+                  <a:srgbClr val="5A6678"/>
+                </a:solidFill>
+                <a:latin typeface="Calibri" pitchFamily="34" charset="0"/>
+                <a:ea typeface="Calibri" pitchFamily="34" charset="-122"/>
+                <a:cs typeface="Calibri" pitchFamily="34" charset="-120"/>
+              </a:rPr>
+              <a:t>23 категории,</a:t>
+            </a:r>
+            <a:endParaRPr lang="en-US" sz="1700" dirty="0"/>
+          </a:p>
+          <a:p>
+            <a:pPr indent="0" marL="0">
+              <a:lnSpc>
+                <a:spcPct val="120000"/>
+              </a:lnSpc>
+              <a:buNone/>
+            </a:pPr>
+            <a:r>
+              <a:rPr lang="en-US" sz="1700" dirty="0">
+                <a:solidFill>
+                  <a:srgbClr val="5A6678"/>
+                </a:solidFill>
+                <a:latin typeface="Calibri" pitchFamily="34" charset="0"/>
+                <a:ea typeface="Calibri" pitchFamily="34" charset="-122"/>
+                <a:cs typeface="Calibri" pitchFamily="34" charset="-120"/>
+              </a:rPr>
+              <a:t>обязательная цитата</a:t>
+            </a:r>
+            <a:endParaRPr lang="en-US" sz="1700" dirty="0"/>
+          </a:p>
+        </p:txBody>
+      </p:sp>
+      <p:sp>
+        <p:nvSpPr>
+          <p:cNvPr id="16" name="Text 14"/>
+          <p:cNvSpPr txBox="1"/>
+          <p:nvPr/>
+        </p:nvSpPr>
+        <p:spPr>
+          <a:xfrm>
+            <a:off x="658368" y="4800600"/>
+            <a:ext cx="10844784" cy="777240"/>
+          </a:xfrm>
+          <a:prstGeom prst="rect">
+            <a:avLst/>
+          </a:prstGeom>
+          <a:noFill/>
+          <a:ln/>
+        </p:spPr>
+        <p:txBody>
+          <a:bodyPr wrap="square" lIns="0" tIns="0" rIns="0" bIns="0" rtlCol="0" anchor="t"/>
+          <a:lstStyle/>
+          <a:p>
+            <a:pPr indent="0" marL="0">
+              <a:lnSpc>
+                <a:spcPct val="120000"/>
+              </a:lnSpc>
+              <a:buNone/>
+            </a:pPr>
+            <a:r>
+              <a:rPr lang="en-US" sz="2400" dirty="0">
+                <a:solidFill>
+                  <a:srgbClr val="1B2E4A"/>
+                </a:solidFill>
+                <a:latin typeface="Calibri" pitchFamily="34" charset="0"/>
+                <a:ea typeface="Calibri" pitchFamily="34" charset="-122"/>
+                <a:cs typeface="Calibri" pitchFamily="34" charset="-120"/>
+              </a:rPr>
+              <a:t>Структуру и критерии проверяет код. Без доступа к модели инструмент продолжает работать.</a:t>
+            </a:r>
+            <a:endParaRPr lang="en-US" sz="2400" dirty="0"/>
+          </a:p>
+        </p:txBody>
+      </p:sp>
+      <p:sp>
+        <p:nvSpPr>
+          <p:cNvPr id="17" name="Text 15"/>
+          <p:cNvSpPr txBox="1"/>
+          <p:nvPr/>
+        </p:nvSpPr>
+        <p:spPr>
+          <a:xfrm>
+            <a:off x="10954512" y="548640"/>
+            <a:ext cx="548640" cy="292608"/>
+          </a:xfrm>
+          <a:prstGeom prst="rect">
+            <a:avLst/>
+          </a:prstGeom>
+          <a:noFill/>
+          <a:ln/>
+        </p:spPr>
+        <p:txBody>
+          <a:bodyPr wrap="square" lIns="0" tIns="0" rIns="0" bIns="0" rtlCol="0" anchor="t"/>
+          <a:lstStyle/>
+          <a:p>
+            <a:pPr algn="r" indent="0" marL="0">
+              <a:buNone/>
+            </a:pPr>
+            <a:r>
+              <a:rPr lang="en-US" sz="1200" spc="100" kern="0" dirty="0">
+                <a:solidFill>
+                  <a:srgbClr val="C3CDD9"/>
+                </a:solidFill>
+                <a:latin typeface="Calibri" pitchFamily="34" charset="0"/>
+                <a:ea typeface="Calibri" pitchFamily="34" charset="-122"/>
+                <a:cs typeface="Calibri" pitchFamily="34" charset="-120"/>
+              </a:rPr>
+              <a:t>08</a:t>
+            </a:r>
+            <a:endParaRPr lang="en-US" sz="1200" dirty="0"/>
+          </a:p>
+        </p:txBody>
+      </p:sp>
+    </p:spTree>
+  </p:cSld>
+  <p:clrMapOvr>
+    <a:masterClrMapping/>
+  </p:clrMapOvr>
+</p:sld>
+</file>
+
+<file path=ppt/slides/slide9.xml><?xml version="1.0" encoding="utf-8"?>
+<p:sld xmlns:a="http://schemas.openxmlformats.org/drawingml/2006/main" xmlns:r="http://schemas.openxmlformats.org/officeDocument/2006/relationships" xmlns:p="http://schemas.openxmlformats.org/presentationml/2006/main">
+  <p:cSld name="Slide 9">
     <p:bg>
       <p:bgPr>
         <a:solidFill>
@@ -5167,7 +5468,7 @@
                 <a:ea typeface="Calibri" pitchFamily="34" charset="-122"/>
                 <a:cs typeface="Calibri" pitchFamily="34" charset="-120"/>
               </a:rPr>
-              <a:t>08</a:t>
+              <a:t>09</a:t>
             </a:r>
             <a:endParaRPr lang="en-US" sz="1200" dirty="0"/>
           </a:p>

</xml_diff>